<commit_message>
Elevate design creativity: Modernized Azure architecture deck with rich brand palettes, visual blueprints, and zero-overlap layout
Co-authored-by: arena-agent <297053741+arena-agent@users.noreply.github.com>
</commit_message>
<xml_diff>
--- a/Azure_Databricks_ADF_Synapse_Architecture.pptx
+++ b/Azure_Databricks_ADF_Synapse_Architecture.pptx
@@ -10,7 +10,6 @@
     <p:sldId id="258" r:id="rId9"/>
     <p:sldId id="259" r:id="rId10"/>
     <p:sldId id="260" r:id="rId11"/>
-    <p:sldId id="261" r:id="rId12"/>
   </p:sldIdLst>
   <p:sldSz cx="9144000" cy="5143500" type="screen4x3"/>
   <p:notesSz cx="6858000" cy="9144000"/>
@@ -3108,7 +3107,7 @@
             <a:avLst/>
           </a:prstGeom>
           <a:solidFill>
-            <a:srgbClr val="0F172A"/>
+            <a:srgbClr val="0A192F"/>
           </a:solidFill>
           <a:ln>
             <a:noFill/>
@@ -3144,14 +3143,14 @@
         </p:nvSpPr>
         <p:spPr>
           <a:xfrm>
-            <a:off x="502920" y="1097280"/>
-            <a:ext cx="146304" cy="2560320"/>
+            <a:off x="0" y="0"/>
+            <a:ext cx="9144000" cy="73152"/>
           </a:xfrm>
           <a:prstGeom prst="rect">
             <a:avLst/>
           </a:prstGeom>
           <a:solidFill>
-            <a:srgbClr val="009CDE"/>
+            <a:srgbClr val="0078D4"/>
           </a:solidFill>
           <a:ln>
             <a:noFill/>
@@ -3181,14 +3180,57 @@
       </p:sp>
       <p:sp>
         <p:nvSpPr>
-          <p:cNvPr id="4" name="TextBox 3"/>
+          <p:cNvPr id="4" name="Rectangle 3"/>
+          <p:cNvSpPr/>
+          <p:nvPr/>
+        </p:nvSpPr>
+        <p:spPr>
+          <a:xfrm>
+            <a:off x="457200" y="1097280"/>
+            <a:ext cx="146304" cy="2651760"/>
+          </a:xfrm>
+          <a:prstGeom prst="rect">
+            <a:avLst/>
+          </a:prstGeom>
+          <a:solidFill>
+            <a:srgbClr val="0078D4"/>
+          </a:solidFill>
+          <a:ln>
+            <a:noFill/>
+          </a:ln>
+        </p:spPr>
+        <p:style>
+          <a:lnRef idx="1">
+            <a:schemeClr val="accent1"/>
+          </a:lnRef>
+          <a:fillRef idx="3">
+            <a:schemeClr val="accent1"/>
+          </a:fillRef>
+          <a:effectRef idx="2">
+            <a:schemeClr val="accent1"/>
+          </a:effectRef>
+          <a:fontRef idx="minor">
+            <a:schemeClr val="lt1"/>
+          </a:fontRef>
+        </p:style>
+        <p:txBody>
+          <a:bodyPr rtlCol="0" anchor="ctr"/>
+          <a:lstStyle/>
+          <a:p>
+            <a:pPr algn="ctr"/>
+          </a:p>
+        </p:txBody>
+      </p:sp>
+      <p:sp>
+        <p:nvSpPr>
+          <p:cNvPr id="5" name="TextBox 4"/>
           <p:cNvSpPr txBox="1"/>
           <p:nvPr/>
         </p:nvSpPr>
         <p:spPr>
           <a:xfrm>
-            <a:off x="822960" y="1143000"/>
-            <a:ext cx="7818119" cy="2926080"/>
+            <a:off x="777240" y="1115568"/>
+            <a:ext cx="4754880" cy="2743200"/>
           </a:xfrm>
           <a:prstGeom prst="rect">
             <a:avLst/>
@@ -3202,13 +3244,118 @@
           <a:lstStyle/>
           <a:p>
             <a:r>
-              <a:rPr sz="1100" b="1">
-                <a:solidFill>
-                  <a:srgbClr val="009CDE"/>
+              <a:rPr sz="1050" b="1">
+                <a:solidFill>
+                  <a:srgbClr val="0078D4"/>
                 </a:solidFill>
                 <a:latin typeface="Georgia"/>
               </a:rPr>
-              <a:t>ENTERPRISE CLOUD DATA ARCHITECTURE ADVISORY
+              <a:t>AZURE DATA ARCHITECTURE STRATEGY
+</a:t>
+            </a:r>
+          </a:p>
+          <a:p>
+            <a:pPr>
+              <a:spcBef>
+                <a:spcPts val="600"/>
+              </a:spcBef>
+            </a:pPr>
+            <a:r>
+              <a:rPr sz="2600" b="1">
+                <a:solidFill>
+                  <a:srgbClr val="FFFFFF"/>
+                </a:solidFill>
+                <a:latin typeface="Georgia"/>
+              </a:rPr>
+              <a:t>Azure Modern Data
+Platform Architecture</a:t>
+            </a:r>
+          </a:p>
+          <a:p>
+            <a:pPr>
+              <a:spcBef>
+                <a:spcPts val="1000"/>
+              </a:spcBef>
+            </a:pPr>
+            <a:r>
+              <a:rPr sz="1150">
+                <a:solidFill>
+                  <a:srgbClr val="EBF5FF"/>
+                </a:solidFill>
+                <a:latin typeface="Microsoft YaHei"/>
+              </a:rPr>
+              <a:t>Azure Data Factory (ADF) · Azure Databricks · Azure Synapse
+三驾马车协同技术架构与湖仓一体化方案建议书</a:t>
+            </a:r>
+          </a:p>
+          <a:p>
+            <a:pPr>
+              <a:spcBef>
+                <a:spcPts val="1600"/>
+              </a:spcBef>
+            </a:pPr>
+            <a:r>
+              <a:rPr sz="850">
+                <a:solidFill>
+                  <a:srgbClr val="64748B"/>
+                </a:solidFill>
+                <a:latin typeface="Microsoft YaHei"/>
+              </a:rPr>
+              <a:t>Cloud Architecture &amp; Data Practice  |  September 2026  |  Confidential</a:t>
+            </a:r>
+          </a:p>
+        </p:txBody>
+      </p:sp>
+      <p:sp>
+        <p:nvSpPr>
+          <p:cNvPr id="6" name="Rounded Rectangle 5"/>
+          <p:cNvSpPr/>
+          <p:nvPr/>
+        </p:nvSpPr>
+        <p:spPr>
+          <a:xfrm>
+            <a:off x="5669280" y="1051560"/>
+            <a:ext cx="3017520" cy="3108960"/>
+          </a:xfrm>
+          <a:prstGeom prst="roundRect">
+            <a:avLst/>
+          </a:prstGeom>
+          <a:solidFill>
+            <a:srgbClr val="0F2140"/>
+          </a:solidFill>
+          <a:ln w="19050">
+            <a:solidFill>
+              <a:srgbClr val="0078D4"/>
+            </a:solidFill>
+          </a:ln>
+        </p:spPr>
+        <p:style>
+          <a:lnRef idx="1">
+            <a:schemeClr val="accent1"/>
+          </a:lnRef>
+          <a:fillRef idx="3">
+            <a:schemeClr val="accent1"/>
+          </a:fillRef>
+          <a:effectRef idx="2">
+            <a:schemeClr val="accent1"/>
+          </a:effectRef>
+          <a:fontRef idx="minor">
+            <a:schemeClr val="lt1"/>
+          </a:fontRef>
+        </p:style>
+        <p:txBody>
+          <a:bodyPr rtlCol="0" anchor="ctr" wrap="square" tIns="109728" lIns="128016" rIns="128016"/>
+          <a:lstStyle/>
+          <a:p>
+            <a:pPr algn="ctr"/>
+            <a:r>
+              <a:rPr sz="950" b="1">
+                <a:solidFill>
+                  <a:srgbClr val="0078D4"/>
+                </a:solidFill>
+                <a:latin typeface="Georgia"/>
+              </a:rPr>
+              <a:t>THE ARCHITECTURE TRIAD (三驾马车)
 </a:t>
             </a:r>
           </a:p>
@@ -3219,13 +3366,105 @@
               </a:spcBef>
             </a:pPr>
             <a:r>
-              <a:rPr sz="2600" b="1">
+              <a:rPr sz="1000" b="1">
                 <a:solidFill>
                   <a:srgbClr val="FFFFFF"/>
                 </a:solidFill>
-                <a:latin typeface="Georgia"/>
-              </a:rPr>
-              <a:t>Azure Modern Data Platform Architecture</a:t>
+                <a:latin typeface="Microsoft YaHei"/>
+              </a:rPr>
+              <a:t>⚡ Azure Data Factory
+</a:t>
+            </a:r>
+            <a:r>
+              <a:rPr sz="700">
+                <a:solidFill>
+                  <a:srgbClr val="0078D4"/>
+                </a:solidFill>
+                <a:latin typeface="Consolas"/>
+              </a:rPr>
+              <a:t>Ingestion &amp; Multi-Source Orchestration
+</a:t>
+            </a:r>
+            <a:r>
+              <a:rPr sz="750">
+                <a:solidFill>
+                  <a:srgbClr val="CBD5E1"/>
+                </a:solidFill>
+                <a:latin typeface="Microsoft YaHei"/>
+              </a:rPr>
+              <a:t>全域混合调度纽带 · 100+ 连接器</a:t>
+            </a:r>
+          </a:p>
+          <a:p>
+            <a:pPr>
+              <a:spcBef>
+                <a:spcPts val="800"/>
+              </a:spcBef>
+            </a:pPr>
+            <a:r>
+              <a:rPr sz="1000" b="1">
+                <a:solidFill>
+                  <a:srgbClr val="FFFFFF"/>
+                </a:solidFill>
+                <a:latin typeface="Microsoft YaHei"/>
+              </a:rPr>
+              <a:t>💎 Azure Databricks
+</a:t>
+            </a:r>
+            <a:r>
+              <a:rPr sz="700">
+                <a:solidFill>
+                  <a:srgbClr val="0078D4"/>
+                </a:solidFill>
+                <a:latin typeface="Consolas"/>
+              </a:rPr>
+              <a:t>Lakehouse Core &amp; AI Computing
+</a:t>
+            </a:r>
+            <a:r>
+              <a:rPr sz="750">
+                <a:solidFill>
+                  <a:srgbClr val="CBD5E1"/>
+                </a:solidFill>
+                <a:latin typeface="Microsoft YaHei"/>
+              </a:rPr>
+              <a:t>Medallion 湖仓计算核心 · Photon 向量化</a:t>
+            </a:r>
+          </a:p>
+          <a:p>
+            <a:pPr>
+              <a:spcBef>
+                <a:spcPts val="800"/>
+              </a:spcBef>
+            </a:pPr>
+            <a:r>
+              <a:rPr sz="1000" b="1">
+                <a:solidFill>
+                  <a:srgbClr val="FFFFFF"/>
+                </a:solidFill>
+                <a:latin typeface="Microsoft YaHei"/>
+              </a:rPr>
+              <a:t>🏛️ Azure Synapse
+</a:t>
+            </a:r>
+            <a:r>
+              <a:rPr sz="700">
+                <a:solidFill>
+                  <a:srgbClr val="0078D4"/>
+                </a:solidFill>
+                <a:latin typeface="Consolas"/>
+              </a:rPr>
+              <a:t>Enterprise Data Warehousing &amp; Serving
+</a:t>
+            </a:r>
+            <a:r>
+              <a:rPr sz="750">
+                <a:solidFill>
+                  <a:srgbClr val="CBD5E1"/>
+                </a:solidFill>
+                <a:latin typeface="Microsoft YaHei"/>
+              </a:rPr>
+              <a:t>专用 SQL 池 MPP · Power BI 极速呈现</a:t>
             </a:r>
           </a:p>
           <a:p>
@@ -3235,47 +3474,13 @@
               </a:spcBef>
             </a:pPr>
             <a:r>
-              <a:rPr sz="1300" b="0">
-                <a:solidFill>
-                  <a:srgbClr val="EAF4FB"/>
-                </a:solidFill>
-                <a:latin typeface="Microsoft YaHei"/>
-              </a:rPr>
-              <a:t>基于 Azure Databricks · ADF · Synapse 的端到端协同技术架构与选型方案建议书</a:t>
-            </a:r>
-          </a:p>
-        </p:txBody>
-      </p:sp>
-      <p:sp>
-        <p:nvSpPr>
-          <p:cNvPr id="5" name="TextBox 4"/>
-          <p:cNvSpPr txBox="1"/>
-          <p:nvPr/>
-        </p:nvSpPr>
-        <p:spPr>
-          <a:xfrm>
-            <a:off x="822960" y="4297680"/>
-            <a:ext cx="7818119" cy="365760"/>
-          </a:xfrm>
-          <a:prstGeom prst="rect">
-            <a:avLst/>
-          </a:prstGeom>
-          <a:noFill/>
-        </p:spPr>
-        <p:txBody>
-          <a:bodyPr wrap="square">
-            <a:spAutoFit/>
-          </a:bodyPr>
-          <a:lstStyle/>
-          <a:p>
-            <a:r>
-              <a:rPr sz="900">
+              <a:rPr sz="700">
                 <a:solidFill>
                   <a:srgbClr val="64748B"/>
                 </a:solidFill>
                 <a:latin typeface="Microsoft YaHei"/>
               </a:rPr>
-              <a:t>Cloud Architecture &amp; Data Practice  |  September 2026  |  Confidential</a:t>
+              <a:t>统一治理中枢：Unity Catalog + Microsoft Purview</a:t>
             </a:r>
           </a:p>
         </p:txBody>
@@ -3306,8 +3511,8 @@
         </p:nvSpPr>
         <p:spPr>
           <a:xfrm>
-            <a:off x="502920" y="256032"/>
-            <a:ext cx="8138159" cy="164592"/>
+            <a:off x="457200" y="237744"/>
+            <a:ext cx="8229600" cy="164592"/>
           </a:xfrm>
           <a:prstGeom prst="rect">
             <a:avLst/>
@@ -3321,7 +3526,7 @@
           <a:lstStyle/>
           <a:p>
             <a:r>
-              <a:rPr sz="750" b="0">
+              <a:rPr sz="750">
                 <a:solidFill>
                   <a:srgbClr val="64748B"/>
                 </a:solidFill>
@@ -3340,8 +3545,8 @@
         </p:nvSpPr>
         <p:spPr>
           <a:xfrm>
-            <a:off x="502920" y="448056"/>
-            <a:ext cx="8138159" cy="347472"/>
+            <a:off x="457200" y="420624"/>
+            <a:ext cx="8229600" cy="329184"/>
           </a:xfrm>
           <a:prstGeom prst="rect">
             <a:avLst/>
@@ -3355,13 +3560,13 @@
           <a:lstStyle/>
           <a:p>
             <a:r>
-              <a:rPr sz="1500" b="1">
+              <a:rPr sz="1450" b="1">
                 <a:solidFill>
                   <a:srgbClr val="0F172A"/>
                 </a:solidFill>
                 <a:latin typeface="Georgia"/>
               </a:rPr>
-              <a:t>战略定位：ADF、Databricks 与 Synapse 各司其职，构建现代湖仓一体分工体系</a:t>
+              <a:t>三驾马车：ADF、Databricks 与 Synapse 各司其职，打破企业选型困惑</a:t>
             </a:r>
           </a:p>
         </p:txBody>
@@ -3374,8 +3579,8 @@
         </p:nvSpPr>
         <p:spPr>
           <a:xfrm>
-            <a:off x="502920" y="822960"/>
-            <a:ext cx="8138159" cy="256032"/>
+            <a:off x="457200" y="768096"/>
+            <a:ext cx="8229600" cy="256032"/>
           </a:xfrm>
           <a:prstGeom prst="rect">
             <a:avLst/>
@@ -3389,13 +3594,13 @@
           <a:lstStyle/>
           <a:p>
             <a:r>
-              <a:rPr sz="1050" b="0">
-                <a:solidFill>
-                  <a:srgbClr val="005A9C"/>
-                </a:solidFill>
-                <a:latin typeface="Microsoft YaHei"/>
-              </a:rPr>
-              <a:t>明确三者在企业数据价值链中的专业分工，打破选型困惑：ADF管调度接入、Databricks管湖仓计算、Synapse管数仓与报表。</a:t>
+              <a:rPr sz="1000" b="0">
+                <a:solidFill>
+                  <a:srgbClr val="0078D4"/>
+                </a:solidFill>
+                <a:latin typeface="Microsoft YaHei"/>
+              </a:rPr>
+              <a:t>明确三者在企业数据价值链中的专业分工：ADF管管道调度、Databricks管湖仓计算与AI、Synapse管数仓与报表消费。</a:t>
             </a:r>
           </a:p>
         </p:txBody>
@@ -3408,8 +3613,8 @@
         </p:nvSpPr>
         <p:spPr>
           <a:xfrm>
-            <a:off x="502920" y="1115568"/>
-            <a:ext cx="8138159" cy="9525"/>
+            <a:off x="457200" y="1060704"/>
+            <a:ext cx="8229600" cy="9525"/>
           </a:xfrm>
           <a:prstGeom prst="rect">
             <a:avLst/>
@@ -3451,8 +3656,8 @@
         </p:nvSpPr>
         <p:spPr>
           <a:xfrm>
-            <a:off x="502920" y="1207008"/>
-            <a:ext cx="2590799" cy="2706624"/>
+            <a:off x="457200" y="1152144"/>
+            <a:ext cx="2621280" cy="2779776"/>
           </a:xfrm>
           <a:prstGeom prst="roundRect">
             <a:avLst/>
@@ -3462,7 +3667,7 @@
           </a:solidFill>
           <a:ln w="12700">
             <a:solidFill>
-              <a:srgbClr val="E2E8F0"/>
+              <a:srgbClr val="CBD5E1"/>
             </a:solidFill>
           </a:ln>
         </p:spPr>
@@ -3481,27 +3686,40 @@
           </a:fontRef>
         </p:style>
         <p:txBody>
-          <a:bodyPr rtlCol="0" anchor="ctr" wrap="square" tIns="109728" bIns="91440" lIns="128016" rIns="128016"/>
+          <a:bodyPr rtlCol="0" anchor="ctr" wrap="square" tIns="164592" bIns="91440" lIns="128016" rIns="128016"/>
           <a:lstStyle/>
           <a:p>
             <a:pPr algn="ctr"/>
             <a:r>
-              <a:rPr sz="1000" b="1">
-                <a:solidFill>
-                  <a:srgbClr val="005A9C"/>
+              <a:rPr sz="850" b="1">
+                <a:solidFill>
+                  <a:srgbClr val="5C2D91"/>
+                </a:solidFill>
+                <a:latin typeface="Microsoft YaHei"/>
+              </a:rPr>
+              <a:t>【全域调度接入纽带】
+</a:t>
+            </a:r>
+          </a:p>
+          <a:p>
+            <a:r>
+              <a:rPr sz="1150" b="1">
+                <a:solidFill>
+                  <a:srgbClr val="0F172A"/>
                 </a:solidFill>
                 <a:latin typeface="Georgia"/>
               </a:rPr>
-              <a:t>[01]  </a:t>
-            </a:r>
-            <a:r>
-              <a:rPr sz="1100" b="1">
-                <a:solidFill>
-                  <a:srgbClr val="0F172A"/>
-                </a:solidFill>
-                <a:latin typeface="Georgia"/>
-              </a:rPr>
-              <a:t>Azure Data Factory (ADF)</a:t>
+              <a:t>Azure Data Factory
+</a:t>
+            </a:r>
+            <a:r>
+              <a:rPr sz="650">
+                <a:solidFill>
+                  <a:srgbClr val="64748B"/>
+                </a:solidFill>
+                <a:latin typeface="Consolas"/>
+              </a:rPr>
+              <a:t>ORCHESTRATION &amp; INGESTION</a:t>
             </a:r>
           </a:p>
           <a:p>
@@ -3509,18 +3727,24 @@
               <a:spcBef>
                 <a:spcPts val="300"/>
               </a:spcBef>
-              <a:spcAft>
-                <a:spcPts val="800"/>
-              </a:spcAft>
             </a:pPr>
             <a:r>
-              <a:rPr sz="850" b="1">
-                <a:solidFill>
-                  <a:srgbClr val="64748B"/>
-                </a:solidFill>
-                <a:latin typeface="Microsoft YaHei"/>
-              </a:rPr>
-              <a:t>全域数据集成与调度编排中枢</a:t>
+              <a:rPr sz="750" b="1">
+                <a:solidFill>
+                  <a:srgbClr val="0F172A"/>
+                </a:solidFill>
+                <a:latin typeface="Microsoft YaHei"/>
+              </a:rPr>
+              <a:t>• 多源连接生态：</a:t>
+            </a:r>
+            <a:r>
+              <a:rPr sz="750">
+                <a:solidFill>
+                  <a:srgbClr val="334155"/>
+                </a:solidFill>
+                <a:latin typeface="Microsoft YaHei"/>
+              </a:rPr>
+              <a:t>内置 100+ 原生成熟连接器，打通本地数据库、云平台与 SaaS。</a:t>
             </a:r>
           </a:p>
           <a:p>
@@ -3528,9 +3752,6 @@
               <a:spcBef>
                 <a:spcPts val="300"/>
               </a:spcBef>
-              <a:spcAft>
-                <a:spcPts val="200"/>
-              </a:spcAft>
             </a:pPr>
             <a:r>
               <a:rPr sz="750" b="1">
@@ -3539,16 +3760,16 @@
                 </a:solidFill>
                 <a:latin typeface="Microsoft YaHei"/>
               </a:rPr>
-              <a:t>• 多源连接生态：</a:t>
-            </a:r>
-            <a:r>
-              <a:rPr sz="750" b="0">
+              <a:t>• Serverless 调度编排：</a:t>
+            </a:r>
+            <a:r>
+              <a:rPr sz="750">
                 <a:solidFill>
                   <a:srgbClr val="334155"/>
                 </a:solidFill>
                 <a:latin typeface="Microsoft YaHei"/>
               </a:rPr>
-              <a:t>内置 100+ 原生成熟连接器，覆盖数据库、多云与 SaaS 应用。</a:t>
+              <a:t>基于事件、时间轮询与动态参数化管道控制，无需常驻服务器。</a:t>
             </a:r>
           </a:p>
           <a:p>
@@ -3556,9 +3777,6 @@
               <a:spcBef>
                 <a:spcPts val="300"/>
               </a:spcBef>
-              <a:spcAft>
-                <a:spcPts val="200"/>
-              </a:spcAft>
             </a:pPr>
             <a:r>
               <a:rPr sz="750" b="1">
@@ -3567,50 +3785,22 @@
                 </a:solidFill>
                 <a:latin typeface="Microsoft YaHei"/>
               </a:rPr>
-              <a:t>• Serverless 弹性调度：</a:t>
-            </a:r>
-            <a:r>
-              <a:rPr sz="750" b="0">
+              <a:t>• 混合内网穿透：</a:t>
+            </a:r>
+            <a:r>
+              <a:rPr sz="750">
                 <a:solidFill>
                   <a:srgbClr val="334155"/>
                 </a:solidFill>
                 <a:latin typeface="Microsoft YaHei"/>
               </a:rPr>
-              <a:t>基于事件触发、定时轮询与参数化依赖编排，无基础设施开销。</a:t>
+              <a:t>自托管运行时 (SHIR) 打通机房专线与 Azure VNet 私有网络。</a:t>
             </a:r>
           </a:p>
           <a:p>
             <a:pPr>
               <a:spcBef>
-                <a:spcPts val="300"/>
-              </a:spcBef>
-              <a:spcAft>
-                <a:spcPts val="200"/>
-              </a:spcAft>
-            </a:pPr>
-            <a:r>
-              <a:rPr sz="750" b="1">
-                <a:solidFill>
-                  <a:srgbClr val="0F172A"/>
-                </a:solidFill>
-                <a:latin typeface="Microsoft YaHei"/>
-              </a:rPr>
-              <a:t>• 安全混合网络：</a:t>
-            </a:r>
-            <a:r>
-              <a:rPr sz="750" b="0">
-                <a:solidFill>
-                  <a:srgbClr val="334155"/>
-                </a:solidFill>
-                <a:latin typeface="Microsoft YaHei"/>
-              </a:rPr>
-              <a:t>自托管运行时 (SHIR) 打通内网与专线，全链路私有端点通信。</a:t>
-            </a:r>
-          </a:p>
-          <a:p>
-            <a:pPr>
-              <a:spcBef>
-                <a:spcPts val="800"/>
+                <a:spcPts val="600"/>
               </a:spcBef>
             </a:pPr>
             <a:r>
@@ -3620,7 +3810,7 @@
                 </a:solidFill>
                 <a:latin typeface="Microsoft YaHei"/>
               </a:rPr>
-              <a:t>✓ 适用场景: </a:t>
+              <a:t>✓ 最佳适用: </a:t>
             </a:r>
             <a:r>
               <a:rPr sz="700">
@@ -3629,7 +3819,7 @@
                 </a:solidFill>
                 <a:latin typeface="Microsoft YaHei"/>
               </a:rPr>
-              <a:t>跨网络数据抽取、轻量文件落湖、作业依赖触发与全域调度。
+              <a:t>跨网络数据抽取、轻量文件落湖、作业触发与全流程自动化编排。
 </a:t>
             </a:r>
             <a:r>
@@ -3648,32 +3838,30 @@
                 </a:solidFill>
                 <a:latin typeface="Microsoft YaHei"/>
               </a:rPr>
-              <a:t>极复杂大数据清洗、非结构化计算与高并发即席查询。</a:t>
-            </a:r>
-          </a:p>
-        </p:txBody>
-      </p:sp>
-      <p:sp>
-        <p:nvSpPr>
-          <p:cNvPr id="7" name="Rounded Rectangle 6"/>
+              <a:t>极复杂大数据清洗、非结构化音视频处理与多分析师交互查询。</a:t>
+            </a:r>
+          </a:p>
+        </p:txBody>
+      </p:sp>
+      <p:sp>
+        <p:nvSpPr>
+          <p:cNvPr id="7" name="Rectangle 6"/>
           <p:cNvSpPr/>
           <p:nvPr/>
         </p:nvSpPr>
         <p:spPr>
           <a:xfrm>
-            <a:off x="3276599" y="1207008"/>
-            <a:ext cx="2590799" cy="2706624"/>
-          </a:xfrm>
-          <a:prstGeom prst="roundRect">
+            <a:off x="530352" y="1225296"/>
+            <a:ext cx="2474976" cy="45720"/>
+          </a:xfrm>
+          <a:prstGeom prst="rect">
             <a:avLst/>
           </a:prstGeom>
           <a:solidFill>
-            <a:srgbClr val="EAF4FB"/>
+            <a:srgbClr val="5C2D91"/>
           </a:solidFill>
-          <a:ln w="19050">
-            <a:solidFill>
-              <a:srgbClr val="009CDE"/>
-            </a:solidFill>
+          <a:ln>
+            <a:noFill/>
           </a:ln>
         </p:spPr>
         <p:style>
@@ -3691,27 +3879,85 @@
           </a:fontRef>
         </p:style>
         <p:txBody>
-          <a:bodyPr rtlCol="0" anchor="ctr" wrap="square" tIns="109728" bIns="91440" lIns="128016" rIns="128016"/>
+          <a:bodyPr rtlCol="0" anchor="ctr"/>
           <a:lstStyle/>
           <a:p>
             <a:pPr algn="ctr"/>
-            <a:r>
-              <a:rPr sz="1000" b="1">
-                <a:solidFill>
-                  <a:srgbClr val="005A9C"/>
+          </a:p>
+        </p:txBody>
+      </p:sp>
+      <p:sp>
+        <p:nvSpPr>
+          <p:cNvPr id="8" name="Rounded Rectangle 7"/>
+          <p:cNvSpPr/>
+          <p:nvPr/>
+        </p:nvSpPr>
+        <p:spPr>
+          <a:xfrm>
+            <a:off x="3261360" y="1152144"/>
+            <a:ext cx="2621280" cy="2779776"/>
+          </a:xfrm>
+          <a:prstGeom prst="roundRect">
+            <a:avLst/>
+          </a:prstGeom>
+          <a:solidFill>
+            <a:srgbClr val="EBF5FF"/>
+          </a:solidFill>
+          <a:ln w="19050">
+            <a:solidFill>
+              <a:srgbClr val="0078D4"/>
+            </a:solidFill>
+          </a:ln>
+        </p:spPr>
+        <p:style>
+          <a:lnRef idx="1">
+            <a:schemeClr val="accent1"/>
+          </a:lnRef>
+          <a:fillRef idx="3">
+            <a:schemeClr val="accent1"/>
+          </a:fillRef>
+          <a:effectRef idx="2">
+            <a:schemeClr val="accent1"/>
+          </a:effectRef>
+          <a:fontRef idx="minor">
+            <a:schemeClr val="lt1"/>
+          </a:fontRef>
+        </p:style>
+        <p:txBody>
+          <a:bodyPr rtlCol="0" anchor="ctr" wrap="square" tIns="164592" bIns="91440" lIns="128016" rIns="128016"/>
+          <a:lstStyle/>
+          <a:p>
+            <a:pPr algn="ctr"/>
+            <a:r>
+              <a:rPr sz="850" b="1">
+                <a:solidFill>
+                  <a:srgbClr val="EA3824"/>
+                </a:solidFill>
+                <a:latin typeface="Microsoft YaHei"/>
+              </a:rPr>
+              <a:t>【👑 湖仓一体计算核心】
+</a:t>
+            </a:r>
+          </a:p>
+          <a:p>
+            <a:r>
+              <a:rPr sz="1150" b="1">
+                <a:solidFill>
+                  <a:srgbClr val="0F172A"/>
                 </a:solidFill>
                 <a:latin typeface="Georgia"/>
               </a:rPr>
-              <a:t>[02]  </a:t>
-            </a:r>
-            <a:r>
-              <a:rPr sz="1100" b="1">
-                <a:solidFill>
-                  <a:srgbClr val="0F172A"/>
-                </a:solidFill>
-                <a:latin typeface="Georgia"/>
-              </a:rPr>
-              <a:t>Azure Databricks</a:t>
+              <a:t>Azure Databricks
+</a:t>
+            </a:r>
+            <a:r>
+              <a:rPr sz="650">
+                <a:solidFill>
+                  <a:srgbClr val="64748B"/>
+                </a:solidFill>
+                <a:latin typeface="Consolas"/>
+              </a:rPr>
+              <a:t>LAKEHOUSE ENGINE &amp; AI</a:t>
             </a:r>
           </a:p>
           <a:p>
@@ -3719,18 +3965,24 @@
               <a:spcBef>
                 <a:spcPts val="300"/>
               </a:spcBef>
-              <a:spcAft>
-                <a:spcPts val="800"/>
-              </a:spcAft>
             </a:pPr>
             <a:r>
-              <a:rPr sz="850" b="1">
-                <a:solidFill>
-                  <a:srgbClr val="005A9C"/>
-                </a:solidFill>
-                <a:latin typeface="Microsoft YaHei"/>
-              </a:rPr>
-              <a:t>现代化湖仓一体与智能计算核心</a:t>
+              <a:rPr sz="750" b="1">
+                <a:solidFill>
+                  <a:srgbClr val="0F172A"/>
+                </a:solidFill>
+                <a:latin typeface="Microsoft YaHei"/>
+              </a:rPr>
+              <a:t>• Medallion 奖章架构：</a:t>
+            </a:r>
+            <a:r>
+              <a:rPr sz="750">
+                <a:solidFill>
+                  <a:srgbClr val="334155"/>
+                </a:solidFill>
+                <a:latin typeface="Microsoft YaHei"/>
+              </a:rPr>
+              <a:t>驱动 Bronze 原始 -&gt; Silver 清洗 -&gt; Gold 业务宽表的逐层精炼。</a:t>
             </a:r>
           </a:p>
           <a:p>
@@ -3738,9 +3990,6 @@
               <a:spcBef>
                 <a:spcPts val="300"/>
               </a:spcBef>
-              <a:spcAft>
-                <a:spcPts val="200"/>
-              </a:spcAft>
             </a:pPr>
             <a:r>
               <a:rPr sz="750" b="1">
@@ -3749,16 +3998,16 @@
                 </a:solidFill>
                 <a:latin typeface="Microsoft YaHei"/>
               </a:rPr>
-              <a:t>• Medallion 奖章架构：</a:t>
-            </a:r>
-            <a:r>
-              <a:rPr sz="750" b="0">
+              <a:t>• 极致大数据性能：</a:t>
+            </a:r>
+            <a:r>
+              <a:rPr sz="750">
                 <a:solidFill>
                   <a:srgbClr val="334155"/>
                 </a:solidFill>
                 <a:latin typeface="Microsoft YaHei"/>
               </a:rPr>
-              <a:t>驱动 Bronze 原始 -&gt; Silver 清洗 -&gt; Gold 业务宽表的逐层精炼。</a:t>
+              <a:t>Photon 向量化执行引擎 + Delta Lake ACID 事务与时间旅行。</a:t>
             </a:r>
           </a:p>
           <a:p>
@@ -3766,9 +4015,6 @@
               <a:spcBef>
                 <a:spcPts val="300"/>
               </a:spcBef>
-              <a:spcAft>
-                <a:spcPts val="200"/>
-              </a:spcAft>
             </a:pPr>
             <a:r>
               <a:rPr sz="750" b="1">
@@ -3777,50 +4023,22 @@
                 </a:solidFill>
                 <a:latin typeface="Microsoft YaHei"/>
               </a:rPr>
-              <a:t>• 极致大数据性能：</a:t>
-            </a:r>
-            <a:r>
-              <a:rPr sz="750" b="0">
+              <a:t>• 统一数据与 AI 治理：</a:t>
+            </a:r>
+            <a:r>
+              <a:rPr sz="750">
                 <a:solidFill>
                   <a:srgbClr val="334155"/>
                 </a:solidFill>
                 <a:latin typeface="Microsoft YaHei"/>
               </a:rPr>
-              <a:t>Photon 向量化执行引擎 + Delta Lake ACID 事务与时间旅行。</a:t>
+              <a:t>Unity Catalog 提供行/列级细粒度权限控制，原生集成 MLflow。</a:t>
             </a:r>
           </a:p>
           <a:p>
             <a:pPr>
               <a:spcBef>
-                <a:spcPts val="300"/>
-              </a:spcBef>
-              <a:spcAft>
-                <a:spcPts val="200"/>
-              </a:spcAft>
-            </a:pPr>
-            <a:r>
-              <a:rPr sz="750" b="1">
-                <a:solidFill>
-                  <a:srgbClr val="0F172A"/>
-                </a:solidFill>
-                <a:latin typeface="Microsoft YaHei"/>
-              </a:rPr>
-              <a:t>• 统一数据与 AI 治理：</a:t>
-            </a:r>
-            <a:r>
-              <a:rPr sz="750" b="0">
-                <a:solidFill>
-                  <a:srgbClr val="334155"/>
-                </a:solidFill>
-                <a:latin typeface="Microsoft YaHei"/>
-              </a:rPr>
-              <a:t>Unity Catalog 提供表/行/列细粒度权限，原生集成 MLflow。</a:t>
-            </a:r>
-          </a:p>
-          <a:p>
-            <a:pPr>
-              <a:spcBef>
-                <a:spcPts val="800"/>
+                <a:spcPts val="600"/>
               </a:spcBef>
             </a:pPr>
             <a:r>
@@ -3830,7 +4048,7 @@
                 </a:solidFill>
                 <a:latin typeface="Microsoft YaHei"/>
               </a:rPr>
-              <a:t>✓ 适用场景: </a:t>
+              <a:t>✓ 最佳适用: </a:t>
             </a:r>
             <a:r>
               <a:rPr sz="700">
@@ -3839,7 +4057,7 @@
                 </a:solidFill>
                 <a:latin typeface="Microsoft YaHei"/>
               </a:rPr>
-              <a:t>流批一体计算、TB/PB 级复杂转换、特征工程与企业私域 AI 模型。
+              <a:t>流批一体计算、TB/PB 级复杂清洗转换、特征工程与企业私域 AI 建模。
 </a:t>
             </a:r>
             <a:r>
@@ -3858,21 +4076,64 @@
                 </a:solidFill>
                 <a:latin typeface="Microsoft YaHei"/>
               </a:rPr>
-              <a:t>简单的点对点文件搬运与数千并发分析师同时在线交互点选。</a:t>
-            </a:r>
-          </a:p>
-        </p:txBody>
-      </p:sp>
-      <p:sp>
-        <p:nvSpPr>
-          <p:cNvPr id="8" name="Rounded Rectangle 7"/>
+              <a:t>简单的点对点文件搬运调度与数千并发人员同时在线点选看板。</a:t>
+            </a:r>
+          </a:p>
+        </p:txBody>
+      </p:sp>
+      <p:sp>
+        <p:nvSpPr>
+          <p:cNvPr id="9" name="Rectangle 8"/>
           <p:cNvSpPr/>
           <p:nvPr/>
         </p:nvSpPr>
         <p:spPr>
           <a:xfrm>
-            <a:off x="6050279" y="1207008"/>
-            <a:ext cx="2590799" cy="2706624"/>
+            <a:off x="3334512" y="1225296"/>
+            <a:ext cx="2474976" cy="45720"/>
+          </a:xfrm>
+          <a:prstGeom prst="rect">
+            <a:avLst/>
+          </a:prstGeom>
+          <a:solidFill>
+            <a:srgbClr val="EA3824"/>
+          </a:solidFill>
+          <a:ln>
+            <a:noFill/>
+          </a:ln>
+        </p:spPr>
+        <p:style>
+          <a:lnRef idx="1">
+            <a:schemeClr val="accent1"/>
+          </a:lnRef>
+          <a:fillRef idx="3">
+            <a:schemeClr val="accent1"/>
+          </a:fillRef>
+          <a:effectRef idx="2">
+            <a:schemeClr val="accent1"/>
+          </a:effectRef>
+          <a:fontRef idx="minor">
+            <a:schemeClr val="lt1"/>
+          </a:fontRef>
+        </p:style>
+        <p:txBody>
+          <a:bodyPr rtlCol="0" anchor="ctr"/>
+          <a:lstStyle/>
+          <a:p>
+            <a:pPr algn="ctr"/>
+          </a:p>
+        </p:txBody>
+      </p:sp>
+      <p:sp>
+        <p:nvSpPr>
+          <p:cNvPr id="10" name="Rounded Rectangle 9"/>
+          <p:cNvSpPr/>
+          <p:nvPr/>
+        </p:nvSpPr>
+        <p:spPr>
+          <a:xfrm>
+            <a:off x="6065520" y="1152144"/>
+            <a:ext cx="2621280" cy="2779776"/>
           </a:xfrm>
           <a:prstGeom prst="roundRect">
             <a:avLst/>
@@ -3882,7 +4143,7 @@
           </a:solidFill>
           <a:ln w="12700">
             <a:solidFill>
-              <a:srgbClr val="E2E8F0"/>
+              <a:srgbClr val="CBD5E1"/>
             </a:solidFill>
           </a:ln>
         </p:spPr>
@@ -3901,27 +4162,40 @@
           </a:fontRef>
         </p:style>
         <p:txBody>
-          <a:bodyPr rtlCol="0" anchor="ctr" wrap="square" tIns="109728" bIns="91440" lIns="128016" rIns="128016"/>
+          <a:bodyPr rtlCol="0" anchor="ctr" wrap="square" tIns="164592" bIns="91440" lIns="128016" rIns="128016"/>
           <a:lstStyle/>
           <a:p>
             <a:pPr algn="ctr"/>
             <a:r>
-              <a:rPr sz="1000" b="1">
-                <a:solidFill>
-                  <a:srgbClr val="005A9C"/>
+              <a:rPr sz="850" b="1">
+                <a:solidFill>
+                  <a:srgbClr val="008272"/>
+                </a:solidFill>
+                <a:latin typeface="Microsoft YaHei"/>
+              </a:rPr>
+              <a:t>【企业数仓与报表消费】
+</a:t>
+            </a:r>
+          </a:p>
+          <a:p>
+            <a:r>
+              <a:rPr sz="1150" b="1">
+                <a:solidFill>
+                  <a:srgbClr val="0F172A"/>
                 </a:solidFill>
                 <a:latin typeface="Georgia"/>
               </a:rPr>
-              <a:t>[03]  </a:t>
-            </a:r>
-            <a:r>
-              <a:rPr sz="1100" b="1">
-                <a:solidFill>
-                  <a:srgbClr val="0F172A"/>
-                </a:solidFill>
-                <a:latin typeface="Georgia"/>
-              </a:rPr>
-              <a:t>Azure Synapse Analytics</a:t>
+              <a:t>Azure Synapse Analytics
+</a:t>
+            </a:r>
+            <a:r>
+              <a:rPr sz="650">
+                <a:solidFill>
+                  <a:srgbClr val="64748B"/>
+                </a:solidFill>
+                <a:latin typeface="Consolas"/>
+              </a:rPr>
+              <a:t>ENTERPRISE SERVING &amp; EDW</a:t>
             </a:r>
           </a:p>
           <a:p>
@@ -3929,18 +4203,24 @@
               <a:spcBef>
                 <a:spcPts val="300"/>
               </a:spcBef>
-              <a:spcAft>
-                <a:spcPts val="800"/>
-              </a:spcAft>
             </a:pPr>
             <a:r>
-              <a:rPr sz="850" b="1">
-                <a:solidFill>
-                  <a:srgbClr val="64748B"/>
-                </a:solidFill>
-                <a:latin typeface="Microsoft YaHei"/>
-              </a:rPr>
-              <a:t>企业级数仓与高性能 BI 报表服务</a:t>
+              <a:rPr sz="750" b="1">
+                <a:solidFill>
+                  <a:srgbClr val="0F172A"/>
+                </a:solidFill>
+                <a:latin typeface="Microsoft YaHei"/>
+              </a:rPr>
+              <a:t>• 专用 SQL 池 (Dedicated)：</a:t>
+            </a:r>
+            <a:r>
+              <a:rPr sz="750">
+                <a:solidFill>
+                  <a:srgbClr val="334155"/>
+                </a:solidFill>
+                <a:latin typeface="Microsoft YaHei"/>
+              </a:rPr>
+              <a:t>MPP 分布式高并发架构，承载企业级数据仓库与星型模型。</a:t>
             </a:r>
           </a:p>
           <a:p>
@@ -3948,9 +4228,6 @@
               <a:spcBef>
                 <a:spcPts val="300"/>
               </a:spcBef>
-              <a:spcAft>
-                <a:spcPts val="200"/>
-              </a:spcAft>
             </a:pPr>
             <a:r>
               <a:rPr sz="750" b="1">
@@ -3959,16 +4236,16 @@
                 </a:solidFill>
                 <a:latin typeface="Microsoft YaHei"/>
               </a:rPr>
-              <a:t>• 专用 SQL 池 (Dedicated)：</a:t>
-            </a:r>
-            <a:r>
-              <a:rPr sz="750" b="0">
+              <a:t>• 无服务器 SQL (Serverless)：</a:t>
+            </a:r>
+            <a:r>
+              <a:rPr sz="750">
                 <a:solidFill>
                   <a:srgbClr val="334155"/>
                 </a:solidFill>
                 <a:latin typeface="Microsoft YaHei"/>
               </a:rPr>
-              <a:t>MPP 分布式高并发架构，承载核心企业数仓与星型模型。</a:t>
+              <a:t>针对湖内文件直接执行原生 T-SQL 探索，按查询数据量计费。</a:t>
             </a:r>
           </a:p>
           <a:p>
@@ -3976,9 +4253,6 @@
               <a:spcBef>
                 <a:spcPts val="300"/>
               </a:spcBef>
-              <a:spcAft>
-                <a:spcPts val="200"/>
-              </a:spcAft>
             </a:pPr>
             <a:r>
               <a:rPr sz="750" b="1">
@@ -3987,50 +4261,22 @@
                 </a:solidFill>
                 <a:latin typeface="Microsoft YaHei"/>
               </a:rPr>
-              <a:t>• 无服务器 SQL (Serverless)：</a:t>
-            </a:r>
-            <a:r>
-              <a:rPr sz="750" b="0">
+              <a:t>• 无缝 Power BI 体验：</a:t>
+            </a:r>
+            <a:r>
+              <a:rPr sz="750">
                 <a:solidFill>
                   <a:srgbClr val="334155"/>
                 </a:solidFill>
                 <a:latin typeface="Microsoft YaHei"/>
               </a:rPr>
-              <a:t>针对湖内文件直接执行原生 T-SQL 探索，按查询量计费。</a:t>
+              <a:t>深度集成 DirectLake 模式，物化视图与缓存保障秒级展现。</a:t>
             </a:r>
           </a:p>
           <a:p>
             <a:pPr>
               <a:spcBef>
-                <a:spcPts val="300"/>
-              </a:spcBef>
-              <a:spcAft>
-                <a:spcPts val="200"/>
-              </a:spcAft>
-            </a:pPr>
-            <a:r>
-              <a:rPr sz="750" b="1">
-                <a:solidFill>
-                  <a:srgbClr val="0F172A"/>
-                </a:solidFill>
-                <a:latin typeface="Microsoft YaHei"/>
-              </a:rPr>
-              <a:t>• 无缝 BI 体验：</a:t>
-            </a:r>
-            <a:r>
-              <a:rPr sz="750" b="0">
-                <a:solidFill>
-                  <a:srgbClr val="334155"/>
-                </a:solidFill>
-                <a:latin typeface="Microsoft YaHei"/>
-              </a:rPr>
-              <a:t>与 Power BI 深度集成，物化视图与 DirectLake 支撑秒级展现。</a:t>
-            </a:r>
-          </a:p>
-          <a:p>
-            <a:pPr>
-              <a:spcBef>
-                <a:spcPts val="800"/>
+                <a:spcPts val="600"/>
               </a:spcBef>
             </a:pPr>
             <a:r>
@@ -4040,7 +4286,7 @@
                 </a:solidFill>
                 <a:latin typeface="Microsoft YaHei"/>
               </a:rPr>
-              <a:t>✓ 适用场景: </a:t>
+              <a:t>✓ 最佳适用: </a:t>
             </a:r>
             <a:r>
               <a:rPr sz="700">
@@ -4049,7 +4295,7 @@
                 </a:solidFill>
                 <a:latin typeface="Microsoft YaHei"/>
               </a:rPr>
-              <a:t>高并发管理仪表盘、复杂维度建模、企业财务级口径治理。
+              <a:t>高并发管理驾驶舱、复杂维度建模与企业财务级统一指标口径。
 </a:t>
             </a:r>
             <a:r>
@@ -4068,32 +4314,30 @@
                 </a:solidFill>
                 <a:latin typeface="Microsoft YaHei"/>
               </a:rPr>
-              <a:t>底层非结构化音视频处理与前沿深度学习模型分布式训练。</a:t>
-            </a:r>
-          </a:p>
-        </p:txBody>
-      </p:sp>
-      <p:sp>
-        <p:nvSpPr>
-          <p:cNvPr id="9" name="Rounded Rectangle 8"/>
+              <a:t>非结构化数据处理与前沿深度学习模型的大规模分布式训练。</a:t>
+            </a:r>
+          </a:p>
+        </p:txBody>
+      </p:sp>
+      <p:sp>
+        <p:nvSpPr>
+          <p:cNvPr id="11" name="Rectangle 10"/>
           <p:cNvSpPr/>
           <p:nvPr/>
         </p:nvSpPr>
         <p:spPr>
           <a:xfrm>
-            <a:off x="502920" y="4462272"/>
-            <a:ext cx="8138159" cy="384048"/>
-          </a:xfrm>
-          <a:prstGeom prst="roundRect">
+            <a:off x="6138672" y="1225296"/>
+            <a:ext cx="2474976" cy="45720"/>
+          </a:xfrm>
+          <a:prstGeom prst="rect">
             <a:avLst/>
           </a:prstGeom>
           <a:solidFill>
-            <a:srgbClr val="EAF4FB"/>
+            <a:srgbClr val="008272"/>
           </a:solidFill>
-          <a:ln w="12700">
-            <a:solidFill>
-              <a:srgbClr val="009CDE"/>
-            </a:solidFill>
+          <a:ln>
+            <a:noFill/>
           </a:ln>
         </p:spPr>
         <p:style>
@@ -4111,6 +4355,51 @@
           </a:fontRef>
         </p:style>
         <p:txBody>
+          <a:bodyPr rtlCol="0" anchor="ctr"/>
+          <a:lstStyle/>
+          <a:p>
+            <a:pPr algn="ctr"/>
+          </a:p>
+        </p:txBody>
+      </p:sp>
+      <p:sp>
+        <p:nvSpPr>
+          <p:cNvPr id="12" name="Rounded Rectangle 11"/>
+          <p:cNvSpPr/>
+          <p:nvPr/>
+        </p:nvSpPr>
+        <p:spPr>
+          <a:xfrm>
+            <a:off x="457200" y="4462272"/>
+            <a:ext cx="8229600" cy="384048"/>
+          </a:xfrm>
+          <a:prstGeom prst="roundRect">
+            <a:avLst/>
+          </a:prstGeom>
+          <a:solidFill>
+            <a:srgbClr val="EBF5FF"/>
+          </a:solidFill>
+          <a:ln w="12700">
+            <a:solidFill>
+              <a:srgbClr val="0078D4"/>
+            </a:solidFill>
+          </a:ln>
+        </p:spPr>
+        <p:style>
+          <a:lnRef idx="1">
+            <a:schemeClr val="accent1"/>
+          </a:lnRef>
+          <a:fillRef idx="3">
+            <a:schemeClr val="accent1"/>
+          </a:fillRef>
+          <a:effectRef idx="2">
+            <a:schemeClr val="accent1"/>
+          </a:effectRef>
+          <a:fontRef idx="minor">
+            <a:schemeClr val="lt1"/>
+          </a:fontRef>
+        </p:style>
+        <p:txBody>
           <a:bodyPr rtlCol="0" anchor="ctr" wrap="square" tIns="54864" bIns="54864" lIns="137160" rIns="137160"/>
           <a:lstStyle/>
           <a:p>
@@ -4118,14 +4407,14 @@
             <a:r>
               <a:rPr sz="850" b="1">
                 <a:solidFill>
-                  <a:srgbClr val="005A9C"/>
+                  <a:srgbClr val="0078D4"/>
                 </a:solidFill>
                 <a:latin typeface="Microsoft YaHei"/>
               </a:rPr>
               <a:t>【架构协同原则】 </a:t>
             </a:r>
             <a:r>
-              <a:rPr sz="850" b="0">
+              <a:rPr sz="800">
                 <a:solidFill>
                   <a:srgbClr val="0F172A"/>
                 </a:solidFill>
@@ -4162,8 +4451,8 @@
         </p:nvSpPr>
         <p:spPr>
           <a:xfrm>
-            <a:off x="502920" y="256032"/>
-            <a:ext cx="8138159" cy="164592"/>
+            <a:off x="457200" y="237744"/>
+            <a:ext cx="8229600" cy="164592"/>
           </a:xfrm>
           <a:prstGeom prst="rect">
             <a:avLst/>
@@ -4177,13 +4466,13 @@
           <a:lstStyle/>
           <a:p>
             <a:r>
-              <a:rPr sz="750" b="0">
+              <a:rPr sz="750">
                 <a:solidFill>
                   <a:srgbClr val="64748B"/>
                 </a:solidFill>
                 <a:latin typeface="Georgia"/>
               </a:rPr>
-              <a:t>AZURE DATA PLATFORM ARCHITECTURE | TECHNICAL BLUEPRINT</a:t>
+              <a:t>AZURE DATA PLATFORM ARCHITECTURE | END-TO-END BLUEPRINT</a:t>
             </a:r>
           </a:p>
         </p:txBody>
@@ -4196,8 +4485,8 @@
         </p:nvSpPr>
         <p:spPr>
           <a:xfrm>
-            <a:off x="502920" y="448056"/>
-            <a:ext cx="8138159" cy="347472"/>
+            <a:off x="457200" y="420624"/>
+            <a:ext cx="8229600" cy="329184"/>
           </a:xfrm>
           <a:prstGeom prst="rect">
             <a:avLst/>
@@ -4211,7 +4500,7 @@
           <a:lstStyle/>
           <a:p>
             <a:r>
-              <a:rPr sz="1500" b="1">
+              <a:rPr sz="1450" b="1">
                 <a:solidFill>
                   <a:srgbClr val="0F172A"/>
                 </a:solidFill>
@@ -4230,8 +4519,8 @@
         </p:nvSpPr>
         <p:spPr>
           <a:xfrm>
-            <a:off x="502920" y="822960"/>
-            <a:ext cx="8138159" cy="256032"/>
+            <a:off x="457200" y="768096"/>
+            <a:ext cx="8229600" cy="256032"/>
           </a:xfrm>
           <a:prstGeom prst="rect">
             <a:avLst/>
@@ -4245,13 +4534,13 @@
           <a:lstStyle/>
           <a:p>
             <a:r>
-              <a:rPr sz="1050" b="0">
-                <a:solidFill>
-                  <a:srgbClr val="005A9C"/>
-                </a:solidFill>
-                <a:latin typeface="Microsoft YaHei"/>
-              </a:rPr>
-              <a:t>分层解耦：多源接入、湖仓精炼、企业数仓建模与全场景消费深度协同，贯穿端到端安全与治理基线。</a:t>
+              <a:rPr sz="1000" b="0">
+                <a:solidFill>
+                  <a:srgbClr val="0078D4"/>
+                </a:solidFill>
+                <a:latin typeface="Microsoft YaHei"/>
+              </a:rPr>
+              <a:t>四层解耦：多源接入、湖仓精炼、企业数仓建模与全场景消费深度协同，贯穿端到端安全与治理基线。</a:t>
             </a:r>
           </a:p>
         </p:txBody>
@@ -4264,8 +4553,8 @@
         </p:nvSpPr>
         <p:spPr>
           <a:xfrm>
-            <a:off x="502920" y="1115568"/>
-            <a:ext cx="8138159" cy="9525"/>
+            <a:off x="457200" y="1060704"/>
+            <a:ext cx="8229600" cy="9525"/>
           </a:xfrm>
           <a:prstGeom prst="rect">
             <a:avLst/>
@@ -4307,7 +4596,7 @@
         </p:nvSpPr>
         <p:spPr>
           <a:xfrm>
-            <a:off x="502920" y="1207008"/>
+            <a:off x="457200" y="1152144"/>
             <a:ext cx="1188720" cy="585216"/>
           </a:xfrm>
           <a:prstGeom prst="roundRect">
@@ -4318,7 +4607,7 @@
           </a:solidFill>
           <a:ln w="9525">
             <a:solidFill>
-              <a:srgbClr val="CBD5E1"/>
+              <a:srgbClr val="0A192F"/>
             </a:solidFill>
           </a:ln>
         </p:spPr>
@@ -4337,18 +4626,18 @@
           </a:fontRef>
         </p:style>
         <p:txBody>
-          <a:bodyPr rtlCol="0" anchor="ctr" wrap="square" tIns="54864" bIns="36576" lIns="73152" rIns="54864"/>
+          <a:bodyPr rtlCol="0" anchor="ctr" wrap="square" tIns="54864" bIns="36576" lIns="54864" rIns="54864"/>
           <a:lstStyle/>
           <a:p>
             <a:pPr algn="ctr"/>
             <a:r>
               <a:rPr sz="850" b="1">
                 <a:solidFill>
-                  <a:srgbClr val="005A9C"/>
+                  <a:srgbClr val="0A192F"/>
                 </a:solidFill>
                 <a:latin typeface="Georgia"/>
               </a:rPr>
-              <a:t>01 消费洞察层
+              <a:t>01 消费与洞察层
 </a:t>
             </a:r>
           </a:p>
@@ -4358,7 +4647,7 @@
                 <a:solidFill>
                   <a:srgbClr val="64748B"/>
                 </a:solidFill>
-                <a:latin typeface="Microsoft YaHei"/>
+                <a:latin typeface="Consolas"/>
               </a:rPr>
               <a:t>CONSUMPTION</a:t>
             </a:r>
@@ -4373,8 +4662,8 @@
         </p:nvSpPr>
         <p:spPr>
           <a:xfrm>
-            <a:off x="1801368" y="1207008"/>
-            <a:ext cx="1655063" cy="585216"/>
+            <a:off x="1737360" y="1152144"/>
+            <a:ext cx="1682496" cy="585216"/>
           </a:xfrm>
           <a:prstGeom prst="roundRect">
             <a:avLst/>
@@ -4382,9 +4671,9 @@
           <a:solidFill>
             <a:srgbClr val="FFFFFF"/>
           </a:solidFill>
-          <a:ln w="9525">
+          <a:ln w="6350">
             <a:solidFill>
-              <a:srgbClr val="E2E8F0"/>
+              <a:srgbClr val="CBD5E1"/>
             </a:solidFill>
           </a:ln>
         </p:spPr>
@@ -4403,26 +4692,22 @@
           </a:fontRef>
         </p:style>
         <p:txBody>
-          <a:bodyPr rtlCol="0" anchor="ctr" wrap="square" bIns="36576" lIns="54864" rIns="54864"/>
+          <a:bodyPr rtlCol="0" anchor="ctr" wrap="square" tIns="36576" bIns="27432" lIns="54864" rIns="54864"/>
           <a:lstStyle/>
           <a:p>
             <a:pPr algn="ctr"/>
             <a:r>
               <a:rPr sz="750" b="1">
                 <a:solidFill>
-                  <a:srgbClr val="005A9C"/>
+                  <a:srgbClr val="0F172A"/>
                 </a:solidFill>
                 <a:latin typeface="Georgia"/>
               </a:rPr>
-              <a:t>Power BI 敏捷可视化</a:t>
-            </a:r>
-          </a:p>
-          <a:p>
-            <a:pPr>
-              <a:spcBef>
-                <a:spcPts val="150"/>
-              </a:spcBef>
-            </a:pPr>
+              <a:t>📊 Power BI 决策看板
+</a:t>
+            </a:r>
+          </a:p>
+          <a:p>
             <a:r>
               <a:rPr sz="650">
                 <a:solidFill>
@@ -4443,8 +4728,8 @@
         </p:nvSpPr>
         <p:spPr>
           <a:xfrm>
-            <a:off x="3529584" y="1207008"/>
-            <a:ext cx="1655063" cy="585216"/>
+            <a:off x="3493008" y="1152144"/>
+            <a:ext cx="1682496" cy="585216"/>
           </a:xfrm>
           <a:prstGeom prst="roundRect">
             <a:avLst/>
@@ -4452,9 +4737,9 @@
           <a:solidFill>
             <a:srgbClr val="FFFFFF"/>
           </a:solidFill>
-          <a:ln w="9525">
+          <a:ln w="6350">
             <a:solidFill>
-              <a:srgbClr val="E2E8F0"/>
+              <a:srgbClr val="CBD5E1"/>
             </a:solidFill>
           </a:ln>
         </p:spPr>
@@ -4473,26 +4758,22 @@
           </a:fontRef>
         </p:style>
         <p:txBody>
-          <a:bodyPr rtlCol="0" anchor="ctr" wrap="square" bIns="36576" lIns="54864" rIns="54864"/>
+          <a:bodyPr rtlCol="0" anchor="ctr" wrap="square" tIns="36576" bIns="27432" lIns="54864" rIns="54864"/>
           <a:lstStyle/>
           <a:p>
             <a:pPr algn="ctr"/>
             <a:r>
               <a:rPr sz="750" b="1">
                 <a:solidFill>
-                  <a:srgbClr val="005A9C"/>
+                  <a:srgbClr val="0F172A"/>
                 </a:solidFill>
                 <a:latin typeface="Georgia"/>
               </a:rPr>
-              <a:t>企业级报表与仪表盘</a:t>
-            </a:r>
-          </a:p>
-          <a:p>
-            <a:pPr>
-              <a:spcBef>
-                <a:spcPts val="150"/>
-              </a:spcBef>
-            </a:pPr>
+              <a:t>📑 企业级合规与财务报表
+</a:t>
+            </a:r>
+          </a:p>
+          <a:p>
             <a:r>
               <a:rPr sz="650">
                 <a:solidFill>
@@ -4500,7 +4781,7 @@
                 </a:solidFill>
                 <a:latin typeface="Microsoft YaHei"/>
               </a:rPr>
-              <a:t>合规财务报表、运营日报与管理驾驶舱，支持定时分发与导出</a:t>
+              <a:t>固定像素报表、多维穿透钻取、审计流水核对，支持定时自动分发</a:t>
             </a:r>
           </a:p>
         </p:txBody>
@@ -4513,8 +4794,8 @@
         </p:nvSpPr>
         <p:spPr>
           <a:xfrm>
-            <a:off x="5257800" y="1207008"/>
-            <a:ext cx="1655063" cy="585216"/>
+            <a:off x="5248656" y="1152144"/>
+            <a:ext cx="1682496" cy="585216"/>
           </a:xfrm>
           <a:prstGeom prst="roundRect">
             <a:avLst/>
@@ -4522,9 +4803,9 @@
           <a:solidFill>
             <a:srgbClr val="FFFFFF"/>
           </a:solidFill>
-          <a:ln w="9525">
+          <a:ln w="6350">
             <a:solidFill>
-              <a:srgbClr val="E2E8F0"/>
+              <a:srgbClr val="CBD5E1"/>
             </a:solidFill>
           </a:ln>
         </p:spPr>
@@ -4543,26 +4824,22 @@
           </a:fontRef>
         </p:style>
         <p:txBody>
-          <a:bodyPr rtlCol="0" anchor="ctr" wrap="square" bIns="36576" lIns="54864" rIns="54864"/>
+          <a:bodyPr rtlCol="0" anchor="ctr" wrap="square" tIns="36576" bIns="27432" lIns="54864" rIns="54864"/>
           <a:lstStyle/>
           <a:p>
             <a:pPr algn="ctr"/>
             <a:r>
               <a:rPr sz="750" b="1">
                 <a:solidFill>
-                  <a:srgbClr val="005A9C"/>
+                  <a:srgbClr val="0F172A"/>
                 </a:solidFill>
                 <a:latin typeface="Georgia"/>
               </a:rPr>
-              <a:t>AI 与大模型应用</a:t>
-            </a:r>
-          </a:p>
-          <a:p>
-            <a:pPr>
-              <a:spcBef>
-                <a:spcPts val="150"/>
-              </a:spcBef>
-            </a:pPr>
+              <a:t>🤖 AI 与大模型应用
+</a:t>
+            </a:r>
+          </a:p>
+          <a:p>
             <a:r>
               <a:rPr sz="650">
                 <a:solidFill>
@@ -4570,7 +4847,7 @@
                 </a:solidFill>
                 <a:latin typeface="Microsoft YaHei"/>
               </a:rPr>
-              <a:t>基于 Azure OpenAI 知识库语义问答与 MLflow 模型在线推理</a:t>
+              <a:t>基于 Azure OpenAI 私域语义问答与 MLflow 模型在线推理服务</a:t>
             </a:r>
           </a:p>
         </p:txBody>
@@ -4583,8 +4860,8 @@
         </p:nvSpPr>
         <p:spPr>
           <a:xfrm>
-            <a:off x="6986015" y="1207008"/>
-            <a:ext cx="1655063" cy="585216"/>
+            <a:off x="7004304" y="1152144"/>
+            <a:ext cx="1682496" cy="585216"/>
           </a:xfrm>
           <a:prstGeom prst="roundRect">
             <a:avLst/>
@@ -4592,9 +4869,9 @@
           <a:solidFill>
             <a:srgbClr val="FFFFFF"/>
           </a:solidFill>
-          <a:ln w="9525">
+          <a:ln w="6350">
             <a:solidFill>
-              <a:srgbClr val="E2E8F0"/>
+              <a:srgbClr val="CBD5E1"/>
             </a:solidFill>
           </a:ln>
         </p:spPr>
@@ -4613,26 +4890,22 @@
           </a:fontRef>
         </p:style>
         <p:txBody>
-          <a:bodyPr rtlCol="0" anchor="ctr" wrap="square" bIns="36576" lIns="54864" rIns="54864"/>
+          <a:bodyPr rtlCol="0" anchor="ctr" wrap="square" tIns="36576" bIns="27432" lIns="54864" rIns="54864"/>
           <a:lstStyle/>
           <a:p>
             <a:pPr algn="ctr"/>
             <a:r>
               <a:rPr sz="750" b="1">
                 <a:solidFill>
-                  <a:srgbClr val="005A9C"/>
+                  <a:srgbClr val="0F172A"/>
                 </a:solidFill>
                 <a:latin typeface="Georgia"/>
               </a:rPr>
-              <a:t>开放 API 与逆向 ETL</a:t>
-            </a:r>
-          </a:p>
-          <a:p>
-            <a:pPr>
-              <a:spcBef>
-                <a:spcPts val="150"/>
-              </a:spcBef>
-            </a:pPr>
+              <a:t>🔌 开放 API 与逆向数据流
+</a:t>
+            </a:r>
+          </a:p>
+          <a:p>
             <a:r>
               <a:rPr sz="650">
                 <a:solidFill>
@@ -4653,8 +4926,8 @@
         </p:nvSpPr>
         <p:spPr>
           <a:xfrm>
-            <a:off x="1801368" y="1792224"/>
-            <a:ext cx="6839711" cy="109728"/>
+            <a:off x="1737360" y="1737360"/>
+            <a:ext cx="6949440" cy="109728"/>
           </a:xfrm>
           <a:prstGeom prst="rect">
             <a:avLst/>
@@ -4675,7 +4948,7 @@
                 </a:solidFill>
                 <a:latin typeface="Consolas"/>
               </a:rPr>
-              <a:t>↕  HTTPS 443 · DirectLake / DirectQuery · REST APIs · OData  ↕</a:t>
+              <a:t>── ↕ DirectLake / DirectQuery 毫秒直读 · HTTPS 443 · REST APIs · OData ──</a:t>
             </a:r>
           </a:p>
         </p:txBody>
@@ -4688,7 +4961,7 @@
         </p:nvSpPr>
         <p:spPr>
           <a:xfrm>
-            <a:off x="502920" y="1901952"/>
+            <a:off x="457200" y="1847088"/>
             <a:ext cx="1188720" cy="585216"/>
           </a:xfrm>
           <a:prstGeom prst="roundRect">
@@ -4699,7 +4972,7 @@
           </a:solidFill>
           <a:ln w="9525">
             <a:solidFill>
-              <a:srgbClr val="CBD5E1"/>
+              <a:srgbClr val="008272"/>
             </a:solidFill>
           </a:ln>
         </p:spPr>
@@ -4718,18 +4991,18 @@
           </a:fontRef>
         </p:style>
         <p:txBody>
-          <a:bodyPr rtlCol="0" anchor="ctr" wrap="square" tIns="54864" bIns="36576" lIns="73152" rIns="54864"/>
+          <a:bodyPr rtlCol="0" anchor="ctr" wrap="square" tIns="54864" bIns="36576" lIns="54864" rIns="54864"/>
           <a:lstStyle/>
           <a:p>
             <a:pPr algn="ctr"/>
             <a:r>
               <a:rPr sz="850" b="1">
                 <a:solidFill>
-                  <a:srgbClr val="005A9C"/>
+                  <a:srgbClr val="008272"/>
                 </a:solidFill>
                 <a:latin typeface="Georgia"/>
               </a:rPr>
-              <a:t>02 建模服务层
+              <a:t>02 数仓与服务层
 </a:t>
             </a:r>
           </a:p>
@@ -4739,7 +5012,7 @@
                 <a:solidFill>
                   <a:srgbClr val="64748B"/>
                 </a:solidFill>
-                <a:latin typeface="Microsoft YaHei"/>
+                <a:latin typeface="Consolas"/>
               </a:rPr>
               <a:t>SERVING &amp; EDW</a:t>
             </a:r>
@@ -4754,8 +5027,8 @@
         </p:nvSpPr>
         <p:spPr>
           <a:xfrm>
-            <a:off x="1801368" y="1901952"/>
-            <a:ext cx="1655063" cy="585216"/>
+            <a:off x="1737360" y="1847088"/>
+            <a:ext cx="1682496" cy="585216"/>
           </a:xfrm>
           <a:prstGeom prst="roundRect">
             <a:avLst/>
@@ -4763,9 +5036,9 @@
           <a:solidFill>
             <a:srgbClr val="FFFFFF"/>
           </a:solidFill>
-          <a:ln w="9525">
+          <a:ln w="6350">
             <a:solidFill>
-              <a:srgbClr val="E2E8F0"/>
+              <a:srgbClr val="CBD5E1"/>
             </a:solidFill>
           </a:ln>
         </p:spPr>
@@ -4784,26 +5057,22 @@
           </a:fontRef>
         </p:style>
         <p:txBody>
-          <a:bodyPr rtlCol="0" anchor="ctr" wrap="square" bIns="36576" lIns="54864" rIns="54864"/>
+          <a:bodyPr rtlCol="0" anchor="ctr" wrap="square" tIns="36576" bIns="27432" lIns="54864" rIns="54864"/>
           <a:lstStyle/>
           <a:p>
             <a:pPr algn="ctr"/>
             <a:r>
               <a:rPr sz="750" b="1">
                 <a:solidFill>
-                  <a:srgbClr val="005A9C"/>
+                  <a:srgbClr val="0F172A"/>
                 </a:solidFill>
                 <a:latin typeface="Georgia"/>
               </a:rPr>
-              <a:t>Synapse 专用 SQL 池</a:t>
-            </a:r>
-          </a:p>
-          <a:p>
-            <a:pPr>
-              <a:spcBef>
-                <a:spcPts val="150"/>
-              </a:spcBef>
-            </a:pPr>
+              <a:t>🏛️ Synapse 专用 SQL 池
+</a:t>
+            </a:r>
+          </a:p>
+          <a:p>
             <a:r>
               <a:rPr sz="650">
                 <a:solidFill>
@@ -4811,7 +5080,7 @@
                 </a:solidFill>
                 <a:latin typeface="Microsoft YaHei"/>
               </a:rPr>
-              <a:t>MPP 分布式企业数仓，承载星型模型 (Fact/Dim)，毫秒高并发</a:t>
+              <a:t>MPP 分布式企业数仓，承载星型模型 (Fact/Dim)，毫秒高并发支持</a:t>
             </a:r>
           </a:p>
         </p:txBody>
@@ -4824,8 +5093,8 @@
         </p:nvSpPr>
         <p:spPr>
           <a:xfrm>
-            <a:off x="3529584" y="1901952"/>
-            <a:ext cx="1655063" cy="585216"/>
+            <a:off x="3493008" y="1847088"/>
+            <a:ext cx="1682496" cy="585216"/>
           </a:xfrm>
           <a:prstGeom prst="roundRect">
             <a:avLst/>
@@ -4833,9 +5102,9 @@
           <a:solidFill>
             <a:srgbClr val="FFFFFF"/>
           </a:solidFill>
-          <a:ln w="9525">
+          <a:ln w="6350">
             <a:solidFill>
-              <a:srgbClr val="E2E8F0"/>
+              <a:srgbClr val="CBD5E1"/>
             </a:solidFill>
           </a:ln>
         </p:spPr>
@@ -4854,26 +5123,22 @@
           </a:fontRef>
         </p:style>
         <p:txBody>
-          <a:bodyPr rtlCol="0" anchor="ctr" wrap="square" bIns="36576" lIns="54864" rIns="54864"/>
+          <a:bodyPr rtlCol="0" anchor="ctr" wrap="square" tIns="36576" bIns="27432" lIns="54864" rIns="54864"/>
           <a:lstStyle/>
           <a:p>
             <a:pPr algn="ctr"/>
             <a:r>
               <a:rPr sz="750" b="1">
                 <a:solidFill>
-                  <a:srgbClr val="005A9C"/>
+                  <a:srgbClr val="0F172A"/>
                 </a:solidFill>
                 <a:latin typeface="Georgia"/>
               </a:rPr>
-              <a:t>Synapse Serverless</a:t>
-            </a:r>
-          </a:p>
-          <a:p>
-            <a:pPr>
-              <a:spcBef>
-                <a:spcPts val="150"/>
-              </a:spcBef>
-            </a:pPr>
+              <a:t>⚡ Synapse Serverless
+</a:t>
+            </a:r>
+          </a:p>
+          <a:p>
             <a:r>
               <a:rPr sz="650">
                 <a:solidFill>
@@ -4894,8 +5159,8 @@
         </p:nvSpPr>
         <p:spPr>
           <a:xfrm>
-            <a:off x="5257800" y="1901952"/>
-            <a:ext cx="1655063" cy="585216"/>
+            <a:off x="5248656" y="1847088"/>
+            <a:ext cx="1682496" cy="585216"/>
           </a:xfrm>
           <a:prstGeom prst="roundRect">
             <a:avLst/>
@@ -4903,9 +5168,9 @@
           <a:solidFill>
             <a:srgbClr val="FFFFFF"/>
           </a:solidFill>
-          <a:ln w="9525">
+          <a:ln w="6350">
             <a:solidFill>
-              <a:srgbClr val="E2E8F0"/>
+              <a:srgbClr val="CBD5E1"/>
             </a:solidFill>
           </a:ln>
         </p:spPr>
@@ -4924,26 +5189,22 @@
           </a:fontRef>
         </p:style>
         <p:txBody>
-          <a:bodyPr rtlCol="0" anchor="ctr" wrap="square" bIns="36576" lIns="54864" rIns="54864"/>
+          <a:bodyPr rtlCol="0" anchor="ctr" wrap="square" tIns="36576" bIns="27432" lIns="54864" rIns="54864"/>
           <a:lstStyle/>
           <a:p>
             <a:pPr algn="ctr"/>
             <a:r>
               <a:rPr sz="750" b="1">
                 <a:solidFill>
-                  <a:srgbClr val="005A9C"/>
+                  <a:srgbClr val="0F172A"/>
                 </a:solidFill>
                 <a:latin typeface="Georgia"/>
               </a:rPr>
-              <a:t>Databricks SQL 仓库</a:t>
-            </a:r>
-          </a:p>
-          <a:p>
-            <a:pPr>
-              <a:spcBef>
-                <a:spcPts val="150"/>
-              </a:spcBef>
-            </a:pPr>
+              <a:t>🎯 Databricks SQL 仓库
+</a:t>
+            </a:r>
+          </a:p>
+          <a:p>
             <a:r>
               <a:rPr sz="650">
                 <a:solidFill>
@@ -4951,7 +5212,7 @@
                 </a:solidFill>
                 <a:latin typeface="Microsoft YaHei"/>
               </a:rPr>
-              <a:t>Serverless SQL Warehouse，提供高性价比湖仓交互式查询</a:t>
+              <a:t>Serverless SQL Warehouse，提供高性价比湖仓交互式查询与语义层</a:t>
             </a:r>
           </a:p>
         </p:txBody>
@@ -4964,8 +5225,8 @@
         </p:nvSpPr>
         <p:spPr>
           <a:xfrm>
-            <a:off x="6986015" y="1901952"/>
-            <a:ext cx="1655063" cy="585216"/>
+            <a:off x="7004304" y="1847088"/>
+            <a:ext cx="1682496" cy="585216"/>
           </a:xfrm>
           <a:prstGeom prst="roundRect">
             <a:avLst/>
@@ -4973,9 +5234,9 @@
           <a:solidFill>
             <a:srgbClr val="FFFFFF"/>
           </a:solidFill>
-          <a:ln w="9525">
+          <a:ln w="6350">
             <a:solidFill>
-              <a:srgbClr val="E2E8F0"/>
+              <a:srgbClr val="CBD5E1"/>
             </a:solidFill>
           </a:ln>
         </p:spPr>
@@ -4994,26 +5255,22 @@
           </a:fontRef>
         </p:style>
         <p:txBody>
-          <a:bodyPr rtlCol="0" anchor="ctr" wrap="square" bIns="36576" lIns="54864" rIns="54864"/>
+          <a:bodyPr rtlCol="0" anchor="ctr" wrap="square" tIns="36576" bIns="27432" lIns="54864" rIns="54864"/>
           <a:lstStyle/>
           <a:p>
             <a:pPr algn="ctr"/>
             <a:r>
               <a:rPr sz="750" b="1">
                 <a:solidFill>
-                  <a:srgbClr val="005A9C"/>
+                  <a:srgbClr val="0F172A"/>
                 </a:solidFill>
                 <a:latin typeface="Georgia"/>
               </a:rPr>
-              <a:t>统一指标管理中枢</a:t>
-            </a:r>
-          </a:p>
-          <a:p>
-            <a:pPr>
-              <a:spcBef>
-                <a:spcPts val="150"/>
-              </a:spcBef>
-            </a:pPr>
+              <a:t>📐 统一指标与度量中枢
+</a:t>
+            </a:r>
+          </a:p>
+          <a:p>
             <a:r>
               <a:rPr sz="650">
                 <a:solidFill>
@@ -5021,7 +5278,7 @@
                 </a:solidFill>
                 <a:latin typeface="Microsoft YaHei"/>
               </a:rPr>
-              <a:t>统一维护全局商业指标口径与语义层，消除跨部门数据歧义</a:t>
+              <a:t>统一维护全局商业指标口径与语义层，彻底消除跨部门数据歧义</a:t>
             </a:r>
           </a:p>
         </p:txBody>
@@ -5034,8 +5291,8 @@
         </p:nvSpPr>
         <p:spPr>
           <a:xfrm>
-            <a:off x="1801368" y="2487168"/>
-            <a:ext cx="6839711" cy="109728"/>
+            <a:off x="1737360" y="2432304"/>
+            <a:ext cx="6949440" cy="109728"/>
           </a:xfrm>
           <a:prstGeom prst="rect">
             <a:avLst/>
@@ -5056,7 +5313,7 @@
                 </a:solidFill>
                 <a:latin typeface="Consolas"/>
               </a:rPr>
-              <a:t>↕  Synapse Link · JDBC / ODBC · T-SQL · Delta Sharing 联邦访问  ↕</a:t>
+              <a:t>── ↕ Synapse Link · T-SQL 存储过程 · Delta Sharing 跨组织安全共享 ──</a:t>
             </a:r>
           </a:p>
         </p:txBody>
@@ -5069,18 +5326,18 @@
         </p:nvSpPr>
         <p:spPr>
           <a:xfrm>
-            <a:off x="502920" y="2596896"/>
+            <a:off x="457200" y="2542032"/>
             <a:ext cx="1188720" cy="585216"/>
           </a:xfrm>
           <a:prstGeom prst="roundRect">
             <a:avLst/>
           </a:prstGeom>
           <a:solidFill>
-            <a:srgbClr val="EAF4FB"/>
+            <a:srgbClr val="EBF5FF"/>
           </a:solidFill>
           <a:ln w="19050">
             <a:solidFill>
-              <a:srgbClr val="009CDE"/>
+              <a:srgbClr val="EA3824"/>
             </a:solidFill>
           </a:ln>
         </p:spPr>
@@ -5099,14 +5356,14 @@
           </a:fontRef>
         </p:style>
         <p:txBody>
-          <a:bodyPr rtlCol="0" anchor="ctr" wrap="square" tIns="54864" bIns="36576" lIns="73152" rIns="54864"/>
+          <a:bodyPr rtlCol="0" anchor="ctr" wrap="square" tIns="54864" bIns="36576" lIns="54864" rIns="54864"/>
           <a:lstStyle/>
           <a:p>
             <a:pPr algn="ctr"/>
             <a:r>
               <a:rPr sz="850" b="1">
                 <a:solidFill>
-                  <a:srgbClr val="005A9C"/>
+                  <a:srgbClr val="EA3824"/>
                 </a:solidFill>
                 <a:latin typeface="Georgia"/>
               </a:rPr>
@@ -5120,7 +5377,7 @@
                 <a:solidFill>
                   <a:srgbClr val="64748B"/>
                 </a:solidFill>
-                <a:latin typeface="Microsoft YaHei"/>
+                <a:latin typeface="Consolas"/>
               </a:rPr>
               <a:t>LAKEHOUSE ENGINE</a:t>
             </a:r>
@@ -5135,8 +5392,8 @@
         </p:nvSpPr>
         <p:spPr>
           <a:xfrm>
-            <a:off x="1801368" y="2596896"/>
-            <a:ext cx="1655063" cy="585216"/>
+            <a:off x="1737360" y="2542032"/>
+            <a:ext cx="1682496" cy="585216"/>
           </a:xfrm>
           <a:prstGeom prst="roundRect">
             <a:avLst/>
@@ -5146,7 +5403,7 @@
           </a:solidFill>
           <a:ln w="12700">
             <a:solidFill>
-              <a:srgbClr val="7FCDEE"/>
+              <a:srgbClr val="0078D4"/>
             </a:solidFill>
           </a:ln>
         </p:spPr>
@@ -5165,26 +5422,22 @@
           </a:fontRef>
         </p:style>
         <p:txBody>
-          <a:bodyPr rtlCol="0" anchor="ctr" wrap="square" bIns="36576" lIns="54864" rIns="54864"/>
+          <a:bodyPr rtlCol="0" anchor="ctr" wrap="square" tIns="36576" bIns="27432" lIns="54864" rIns="54864"/>
           <a:lstStyle/>
           <a:p>
             <a:pPr algn="ctr"/>
             <a:r>
               <a:rPr sz="750" b="1">
                 <a:solidFill>
-                  <a:srgbClr val="005A9C"/>
+                  <a:srgbClr val="0F172A"/>
                 </a:solidFill>
                 <a:latin typeface="Georgia"/>
               </a:rPr>
-              <a:t>Bronze 原始湖 (Raw)</a:t>
-            </a:r>
-          </a:p>
-          <a:p>
-            <a:pPr>
-              <a:spcBef>
-                <a:spcPts val="150"/>
-              </a:spcBef>
-            </a:pPr>
+              <a:t>🥉 Bronze 原始湖 (Raw)
+</a:t>
+            </a:r>
+          </a:p>
+          <a:p>
             <a:r>
               <a:rPr sz="650">
                 <a:solidFill>
@@ -5192,7 +5445,7 @@
                 </a:solidFill>
                 <a:latin typeface="Microsoft YaHei"/>
               </a:rPr>
-              <a:t>保留源端 1:1 原始快照与增量日志，Auto Loader 毫秒入湖</a:t>
+              <a:t>保留源端 1:1 快照与增量日志，Auto Loader 毫秒入湖，版本回溯</a:t>
             </a:r>
           </a:p>
         </p:txBody>
@@ -5205,8 +5458,8 @@
         </p:nvSpPr>
         <p:spPr>
           <a:xfrm>
-            <a:off x="3529584" y="2596896"/>
-            <a:ext cx="1655063" cy="585216"/>
+            <a:off x="3493008" y="2542032"/>
+            <a:ext cx="1682496" cy="585216"/>
           </a:xfrm>
           <a:prstGeom prst="roundRect">
             <a:avLst/>
@@ -5216,7 +5469,7 @@
           </a:solidFill>
           <a:ln w="12700">
             <a:solidFill>
-              <a:srgbClr val="7FCDEE"/>
+              <a:srgbClr val="0078D4"/>
             </a:solidFill>
           </a:ln>
         </p:spPr>
@@ -5235,26 +5488,22 @@
           </a:fontRef>
         </p:style>
         <p:txBody>
-          <a:bodyPr rtlCol="0" anchor="ctr" wrap="square" bIns="36576" lIns="54864" rIns="54864"/>
+          <a:bodyPr rtlCol="0" anchor="ctr" wrap="square" tIns="36576" bIns="27432" lIns="54864" rIns="54864"/>
           <a:lstStyle/>
           <a:p>
             <a:pPr algn="ctr"/>
             <a:r>
               <a:rPr sz="750" b="1">
                 <a:solidFill>
-                  <a:srgbClr val="005A9C"/>
+                  <a:srgbClr val="0F172A"/>
                 </a:solidFill>
                 <a:latin typeface="Georgia"/>
               </a:rPr>
-              <a:t>Silver 洁净层 (Refined)</a:t>
-            </a:r>
-          </a:p>
-          <a:p>
-            <a:pPr>
-              <a:spcBef>
-                <a:spcPts val="150"/>
-              </a:spcBef>
-            </a:pPr>
+              <a:t>🥈 Silver 洁净层 (Refined)
+</a:t>
+            </a:r>
+          </a:p>
+          <a:p>
             <a:r>
               <a:rPr sz="650">
                 <a:solidFill>
@@ -5262,7 +5511,7 @@
                 </a:solidFill>
                 <a:latin typeface="Microsoft YaHei"/>
               </a:rPr>
-              <a:t>执行清洗、去重、类型推断、Schema 校验与实体关联 (Delta 表)</a:t>
+              <a:t>执行清洗去重、类型推断、Schema 演进验证与异常数据分流 (Delta)</a:t>
             </a:r>
           </a:p>
         </p:txBody>
@@ -5275,8 +5524,8 @@
         </p:nvSpPr>
         <p:spPr>
           <a:xfrm>
-            <a:off x="5257800" y="2596896"/>
-            <a:ext cx="1655063" cy="585216"/>
+            <a:off x="5248656" y="2542032"/>
+            <a:ext cx="1682496" cy="585216"/>
           </a:xfrm>
           <a:prstGeom prst="roundRect">
             <a:avLst/>
@@ -5286,7 +5535,7 @@
           </a:solidFill>
           <a:ln w="12700">
             <a:solidFill>
-              <a:srgbClr val="7FCDEE"/>
+              <a:srgbClr val="0078D4"/>
             </a:solidFill>
           </a:ln>
         </p:spPr>
@@ -5305,26 +5554,22 @@
           </a:fontRef>
         </p:style>
         <p:txBody>
-          <a:bodyPr rtlCol="0" anchor="ctr" wrap="square" bIns="36576" lIns="54864" rIns="54864"/>
+          <a:bodyPr rtlCol="0" anchor="ctr" wrap="square" tIns="36576" bIns="27432" lIns="54864" rIns="54864"/>
           <a:lstStyle/>
           <a:p>
             <a:pPr algn="ctr"/>
             <a:r>
               <a:rPr sz="750" b="1">
                 <a:solidFill>
-                  <a:srgbClr val="005A9C"/>
+                  <a:srgbClr val="0F172A"/>
                 </a:solidFill>
                 <a:latin typeface="Georgia"/>
               </a:rPr>
-              <a:t>Gold 业务层 (Curated)</a:t>
-            </a:r>
-          </a:p>
-          <a:p>
-            <a:pPr>
-              <a:spcBef>
-                <a:spcPts val="150"/>
-              </a:spcBef>
-            </a:pPr>
+              <a:t>🥇 Gold 业务层 (Curated)
+</a:t>
+            </a:r>
+          </a:p>
+          <a:p>
             <a:r>
               <a:rPr sz="650">
                 <a:solidFill>
@@ -5332,7 +5577,7 @@
                 </a:solidFill>
                 <a:latin typeface="Microsoft YaHei"/>
               </a:rPr>
-              <a:t>高度精炼的主题汇总宽表、业务指标预计算与特征库，ACID 保障</a:t>
+              <a:t>高度精炼的主题宽表、业务指标预计算与算法特征库，ACID 保障</a:t>
             </a:r>
           </a:p>
         </p:txBody>
@@ -5345,8 +5590,8 @@
         </p:nvSpPr>
         <p:spPr>
           <a:xfrm>
-            <a:off x="6986015" y="2596896"/>
-            <a:ext cx="1655063" cy="585216"/>
+            <a:off x="7004304" y="2542032"/>
+            <a:ext cx="1682496" cy="585216"/>
           </a:xfrm>
           <a:prstGeom prst="roundRect">
             <a:avLst/>
@@ -5356,7 +5601,7 @@
           </a:solidFill>
           <a:ln w="12700">
             <a:solidFill>
-              <a:srgbClr val="7FCDEE"/>
+              <a:srgbClr val="0078D4"/>
             </a:solidFill>
           </a:ln>
         </p:spPr>
@@ -5375,26 +5620,22 @@
           </a:fontRef>
         </p:style>
         <p:txBody>
-          <a:bodyPr rtlCol="0" anchor="ctr" wrap="square" bIns="36576" lIns="54864" rIns="54864"/>
+          <a:bodyPr rtlCol="0" anchor="ctr" wrap="square" tIns="36576" bIns="27432" lIns="54864" rIns="54864"/>
           <a:lstStyle/>
           <a:p>
             <a:pPr algn="ctr"/>
             <a:r>
               <a:rPr sz="750" b="1">
                 <a:solidFill>
-                  <a:srgbClr val="005A9C"/>
+                  <a:srgbClr val="0F172A"/>
                 </a:solidFill>
                 <a:latin typeface="Georgia"/>
               </a:rPr>
-              <a:t>Unity Catalog 统一治理</a:t>
-            </a:r>
-          </a:p>
-          <a:p>
-            <a:pPr>
-              <a:spcBef>
-                <a:spcPts val="150"/>
-              </a:spcBef>
-            </a:pPr>
+              <a:t>🛡️ Unity Catalog 统一治理
+</a:t>
+            </a:r>
+          </a:p>
+          <a:p>
             <a:r>
               <a:rPr sz="650">
                 <a:solidFill>
@@ -5415,8 +5656,8 @@
         </p:nvSpPr>
         <p:spPr>
           <a:xfrm>
-            <a:off x="1801368" y="3182112"/>
-            <a:ext cx="6839711" cy="109728"/>
+            <a:off x="1737360" y="3127248"/>
+            <a:ext cx="6949440" cy="109728"/>
           </a:xfrm>
           <a:prstGeom prst="rect">
             <a:avLst/>
@@ -5437,7 +5678,7 @@
                 </a:solidFill>
                 <a:latin typeface="Consolas"/>
               </a:rPr>
-              <a:t>↕  ABFS (ADLS Gen2) · Delta Lake 开放格式 · Apache Spark 3.x · Auto Loader  ↕</a:t>
+              <a:t>── ↕ ABFS (ADLS Gen2) · Delta Lake 开放格式 · Apache Spark 3.x · Auto Loader ──</a:t>
             </a:r>
           </a:p>
         </p:txBody>
@@ -5450,7 +5691,7 @@
         </p:nvSpPr>
         <p:spPr>
           <a:xfrm>
-            <a:off x="502920" y="3291840"/>
+            <a:off x="457200" y="3236976"/>
             <a:ext cx="1188720" cy="585216"/>
           </a:xfrm>
           <a:prstGeom prst="roundRect">
@@ -5461,7 +5702,7 @@
           </a:solidFill>
           <a:ln w="9525">
             <a:solidFill>
-              <a:srgbClr val="CBD5E1"/>
+              <a:srgbClr val="5C2D91"/>
             </a:solidFill>
           </a:ln>
         </p:spPr>
@@ -5480,18 +5721,18 @@
           </a:fontRef>
         </p:style>
         <p:txBody>
-          <a:bodyPr rtlCol="0" anchor="ctr" wrap="square" tIns="54864" bIns="36576" lIns="73152" rIns="54864"/>
+          <a:bodyPr rtlCol="0" anchor="ctr" wrap="square" tIns="54864" bIns="36576" lIns="54864" rIns="54864"/>
           <a:lstStyle/>
           <a:p>
             <a:pPr algn="ctr"/>
             <a:r>
               <a:rPr sz="850" b="1">
                 <a:solidFill>
-                  <a:srgbClr val="005A9C"/>
+                  <a:srgbClr val="5C2D91"/>
                 </a:solidFill>
                 <a:latin typeface="Georgia"/>
               </a:rPr>
-              <a:t>04 接入基建层
+              <a:t>04 接入与基建层
 </a:t>
             </a:r>
           </a:p>
@@ -5501,7 +5742,7 @@
                 <a:solidFill>
                   <a:srgbClr val="64748B"/>
                 </a:solidFill>
-                <a:latin typeface="Microsoft YaHei"/>
+                <a:latin typeface="Consolas"/>
               </a:rPr>
               <a:t>INGESTION &amp; INFRA</a:t>
             </a:r>
@@ -5516,8 +5757,8 @@
         </p:nvSpPr>
         <p:spPr>
           <a:xfrm>
-            <a:off x="1801368" y="3291840"/>
-            <a:ext cx="1655063" cy="585216"/>
+            <a:off x="1737360" y="3236976"/>
+            <a:ext cx="1682496" cy="585216"/>
           </a:xfrm>
           <a:prstGeom prst="roundRect">
             <a:avLst/>
@@ -5525,9 +5766,9 @@
           <a:solidFill>
             <a:srgbClr val="FFFFFF"/>
           </a:solidFill>
-          <a:ln w="9525">
+          <a:ln w="6350">
             <a:solidFill>
-              <a:srgbClr val="E2E8F0"/>
+              <a:srgbClr val="CBD5E1"/>
             </a:solidFill>
           </a:ln>
         </p:spPr>
@@ -5546,26 +5787,22 @@
           </a:fontRef>
         </p:style>
         <p:txBody>
-          <a:bodyPr rtlCol="0" anchor="ctr" wrap="square" bIns="36576" lIns="54864" rIns="54864"/>
+          <a:bodyPr rtlCol="0" anchor="ctr" wrap="square" tIns="36576" bIns="27432" lIns="54864" rIns="54864"/>
           <a:lstStyle/>
           <a:p>
             <a:pPr algn="ctr"/>
             <a:r>
               <a:rPr sz="750" b="1">
                 <a:solidFill>
-                  <a:srgbClr val="005A9C"/>
+                  <a:srgbClr val="0F172A"/>
                 </a:solidFill>
                 <a:latin typeface="Georgia"/>
               </a:rPr>
-              <a:t>Azure Data Factory (ADF)</a:t>
-            </a:r>
-          </a:p>
-          <a:p>
-            <a:pPr>
-              <a:spcBef>
-                <a:spcPts val="150"/>
-              </a:spcBef>
-            </a:pPr>
+              <a:t>⚡ Azure Data Factory (ADF)
+</a:t>
+            </a:r>
+          </a:p>
+          <a:p>
             <a:r>
               <a:rPr sz="650">
                 <a:solidFill>
@@ -5573,7 +5810,7 @@
                 </a:solidFill>
                 <a:latin typeface="Microsoft YaHei"/>
               </a:rPr>
-              <a:t>全域统一调度编排流水线，支持 100+ 连接器与断点续传</a:t>
+              <a:t>全域统一调度编排流水线，支持 100+ 异构连接器与断点续传</a:t>
             </a:r>
           </a:p>
         </p:txBody>
@@ -5586,8 +5823,8 @@
         </p:nvSpPr>
         <p:spPr>
           <a:xfrm>
-            <a:off x="3529584" y="3291840"/>
-            <a:ext cx="1655063" cy="585216"/>
+            <a:off x="3493008" y="3236976"/>
+            <a:ext cx="1682496" cy="585216"/>
           </a:xfrm>
           <a:prstGeom prst="roundRect">
             <a:avLst/>
@@ -5595,9 +5832,9 @@
           <a:solidFill>
             <a:srgbClr val="FFFFFF"/>
           </a:solidFill>
-          <a:ln w="9525">
+          <a:ln w="6350">
             <a:solidFill>
-              <a:srgbClr val="E2E8F0"/>
+              <a:srgbClr val="CBD5E1"/>
             </a:solidFill>
           </a:ln>
         </p:spPr>
@@ -5616,26 +5853,22 @@
           </a:fontRef>
         </p:style>
         <p:txBody>
-          <a:bodyPr rtlCol="0" anchor="ctr" wrap="square" bIns="36576" lIns="54864" rIns="54864"/>
+          <a:bodyPr rtlCol="0" anchor="ctr" wrap="square" tIns="36576" bIns="27432" lIns="54864" rIns="54864"/>
           <a:lstStyle/>
           <a:p>
             <a:pPr algn="ctr"/>
             <a:r>
               <a:rPr sz="750" b="1">
                 <a:solidFill>
-                  <a:srgbClr val="005A9C"/>
+                  <a:srgbClr val="0F172A"/>
                 </a:solidFill>
                 <a:latin typeface="Georgia"/>
               </a:rPr>
-              <a:t>Event Hubs 实时流接入</a:t>
-            </a:r>
-          </a:p>
-          <a:p>
-            <a:pPr>
-              <a:spcBef>
-                <a:spcPts val="150"/>
-              </a:spcBef>
-            </a:pPr>
+              <a:t>📡 Event Hubs 实时流接入
+</a:t>
+            </a:r>
+          </a:p>
+          <a:p>
             <a:r>
               <a:rPr sz="650">
                 <a:solidFill>
@@ -5656,8 +5889,8 @@
         </p:nvSpPr>
         <p:spPr>
           <a:xfrm>
-            <a:off x="5257800" y="3291840"/>
-            <a:ext cx="1655063" cy="585216"/>
+            <a:off x="5248656" y="3236976"/>
+            <a:ext cx="1682496" cy="585216"/>
           </a:xfrm>
           <a:prstGeom prst="roundRect">
             <a:avLst/>
@@ -5665,9 +5898,9 @@
           <a:solidFill>
             <a:srgbClr val="FFFFFF"/>
           </a:solidFill>
-          <a:ln w="9525">
+          <a:ln w="6350">
             <a:solidFill>
-              <a:srgbClr val="E2E8F0"/>
+              <a:srgbClr val="CBD5E1"/>
             </a:solidFill>
           </a:ln>
         </p:spPr>
@@ -5686,26 +5919,22 @@
           </a:fontRef>
         </p:style>
         <p:txBody>
-          <a:bodyPr rtlCol="0" anchor="ctr" wrap="square" bIns="36576" lIns="54864" rIns="54864"/>
+          <a:bodyPr rtlCol="0" anchor="ctr" wrap="square" tIns="36576" bIns="27432" lIns="54864" rIns="54864"/>
           <a:lstStyle/>
           <a:p>
             <a:pPr algn="ctr"/>
             <a:r>
               <a:rPr sz="750" b="1">
                 <a:solidFill>
-                  <a:srgbClr val="005A9C"/>
+                  <a:srgbClr val="0F172A"/>
                 </a:solidFill>
                 <a:latin typeface="Georgia"/>
               </a:rPr>
-              <a:t>ADLS Gen2 湖存储底座</a:t>
-            </a:r>
-          </a:p>
-          <a:p>
-            <a:pPr>
-              <a:spcBef>
-                <a:spcPts val="150"/>
-              </a:spcBef>
-            </a:pPr>
+              <a:t>🗄️ ADLS Gen2 湖存储底座
+</a:t>
+            </a:r>
+          </a:p>
+          <a:p>
             <a:r>
               <a:rPr sz="650">
                 <a:solidFill>
@@ -5713,7 +5942,7 @@
                 </a:solidFill>
                 <a:latin typeface="Microsoft YaHei"/>
               </a:rPr>
-              <a:t>高性价比分层存储 (Hot/Cool/Archive)，多协议兼容与加密</a:t>
+              <a:t>高性价比分层存储 (Hot/Cool/Archive)，多协议兼容与静态加密</a:t>
             </a:r>
           </a:p>
         </p:txBody>
@@ -5726,8 +5955,8 @@
         </p:nvSpPr>
         <p:spPr>
           <a:xfrm>
-            <a:off x="6986015" y="3291840"/>
-            <a:ext cx="1655063" cy="585216"/>
+            <a:off x="7004304" y="3236976"/>
+            <a:ext cx="1682496" cy="585216"/>
           </a:xfrm>
           <a:prstGeom prst="roundRect">
             <a:avLst/>
@@ -5735,9 +5964,9 @@
           <a:solidFill>
             <a:srgbClr val="FFFFFF"/>
           </a:solidFill>
-          <a:ln w="9525">
+          <a:ln w="6350">
             <a:solidFill>
-              <a:srgbClr val="E2E8F0"/>
+              <a:srgbClr val="CBD5E1"/>
             </a:solidFill>
           </a:ln>
         </p:spPr>
@@ -5756,26 +5985,22 @@
           </a:fontRef>
         </p:style>
         <p:txBody>
-          <a:bodyPr rtlCol="0" anchor="ctr" wrap="square" bIns="36576" lIns="54864" rIns="54864"/>
+          <a:bodyPr rtlCol="0" anchor="ctr" wrap="square" tIns="36576" bIns="27432" lIns="54864" rIns="54864"/>
           <a:lstStyle/>
           <a:p>
             <a:pPr algn="ctr"/>
             <a:r>
               <a:rPr sz="750" b="1">
                 <a:solidFill>
-                  <a:srgbClr val="005A9C"/>
+                  <a:srgbClr val="0F172A"/>
                 </a:solidFill>
                 <a:latin typeface="Georgia"/>
               </a:rPr>
-              <a:t>多源异构业务系统</a:t>
-            </a:r>
-          </a:p>
-          <a:p>
-            <a:pPr>
-              <a:spcBef>
-                <a:spcPts val="150"/>
-              </a:spcBef>
-            </a:pPr>
+              <a:t>🏢 企业多源业务系统
+</a:t>
+            </a:r>
+          </a:p>
+          <a:p>
             <a:r>
               <a:rPr sz="650">
                 <a:solidFill>
@@ -5783,7 +6008,7 @@
                 </a:solidFill>
                 <a:latin typeface="Microsoft YaHei"/>
               </a:rPr>
-              <a:t>SAP ERP、本地核心数据库、SaaS CRM、无结构音视频附件</a:t>
+              <a:t>SAP ERP、本地核心数据库、SaaS CRM 与各类无结构附件文件</a:t>
             </a:r>
           </a:p>
         </p:txBody>
@@ -5796,8 +6021,8 @@
         </p:nvSpPr>
         <p:spPr>
           <a:xfrm>
-            <a:off x="502920" y="3913632"/>
-            <a:ext cx="8138159" cy="219456"/>
+            <a:off x="457200" y="3858768"/>
+            <a:ext cx="8229600" cy="219456"/>
           </a:xfrm>
           <a:prstGeom prst="roundRect">
             <a:avLst/>
@@ -5833,11 +6058,11 @@
             <a:r>
               <a:rPr sz="700" b="1">
                 <a:solidFill>
-                  <a:srgbClr val="005A9C"/>
-                </a:solidFill>
-                <a:latin typeface="Microsoft YaHei"/>
-              </a:rPr>
-              <a:t>🛡️ 统一治理与安全底座：Microsoft Purview 数据编织 · Azure Key Vault 统一密钥 · Entra ID 单点鉴权 · 全私有端点 (Private Link)</a:t>
+                  <a:srgbClr val="0078D4"/>
+                </a:solidFill>
+                <a:latin typeface="Microsoft YaHei"/>
+              </a:rPr>
+              <a:t>🔐 全局安全与治理底座：Microsoft Purview 数据编织 · Azure Key Vault 统一密钥 · Entra ID 单点鉴权 · 全私有端点 (Private Link)</a:t>
             </a:r>
           </a:p>
         </p:txBody>
@@ -5850,18 +6075,18 @@
         </p:nvSpPr>
         <p:spPr>
           <a:xfrm>
-            <a:off x="502920" y="4462272"/>
-            <a:ext cx="8138159" cy="384048"/>
+            <a:off x="457200" y="4462272"/>
+            <a:ext cx="8229600" cy="384048"/>
           </a:xfrm>
           <a:prstGeom prst="roundRect">
             <a:avLst/>
           </a:prstGeom>
           <a:solidFill>
-            <a:srgbClr val="EAF4FB"/>
+            <a:srgbClr val="EBF5FF"/>
           </a:solidFill>
           <a:ln w="12700">
             <a:solidFill>
-              <a:srgbClr val="009CDE"/>
+              <a:srgbClr val="0078D4"/>
             </a:solidFill>
           </a:ln>
         </p:spPr>
@@ -5887,14 +6112,14 @@
             <a:r>
               <a:rPr sz="850" b="1">
                 <a:solidFill>
-                  <a:srgbClr val="005A9C"/>
+                  <a:srgbClr val="0078D4"/>
                 </a:solidFill>
                 <a:latin typeface="Microsoft YaHei"/>
               </a:rPr>
               <a:t>【核心设计原则】 </a:t>
             </a:r>
             <a:r>
-              <a:rPr sz="850" b="0">
+              <a:rPr sz="800">
                 <a:solidFill>
                   <a:srgbClr val="0F172A"/>
                 </a:solidFill>
@@ -5931,8 +6156,8 @@
         </p:nvSpPr>
         <p:spPr>
           <a:xfrm>
-            <a:off x="502920" y="256032"/>
-            <a:ext cx="8138159" cy="164592"/>
+            <a:off x="457200" y="237744"/>
+            <a:ext cx="8229600" cy="164592"/>
           </a:xfrm>
           <a:prstGeom prst="rect">
             <a:avLst/>
@@ -5946,7 +6171,7 @@
           <a:lstStyle/>
           <a:p>
             <a:r>
-              <a:rPr sz="750" b="0">
+              <a:rPr sz="750">
                 <a:solidFill>
                   <a:srgbClr val="64748B"/>
                 </a:solidFill>
@@ -5965,8 +6190,8 @@
         </p:nvSpPr>
         <p:spPr>
           <a:xfrm>
-            <a:off x="502920" y="448056"/>
-            <a:ext cx="8138159" cy="347472"/>
+            <a:off x="457200" y="420624"/>
+            <a:ext cx="8229600" cy="329184"/>
           </a:xfrm>
           <a:prstGeom prst="rect">
             <a:avLst/>
@@ -5980,7 +6205,7 @@
           <a:lstStyle/>
           <a:p>
             <a:r>
-              <a:rPr sz="1500" b="1">
+              <a:rPr sz="1450" b="1">
                 <a:solidFill>
                   <a:srgbClr val="0F172A"/>
                 </a:solidFill>
@@ -5999,8 +6224,8 @@
         </p:nvSpPr>
         <p:spPr>
           <a:xfrm>
-            <a:off x="502920" y="822960"/>
-            <a:ext cx="8138159" cy="256032"/>
+            <a:off x="457200" y="768096"/>
+            <a:ext cx="8229600" cy="256032"/>
           </a:xfrm>
           <a:prstGeom prst="rect">
             <a:avLst/>
@@ -6014,9 +6239,9 @@
           <a:lstStyle/>
           <a:p>
             <a:r>
-              <a:rPr sz="1050" b="0">
-                <a:solidFill>
-                  <a:srgbClr val="005A9C"/>
+              <a:rPr sz="1000" b="0">
+                <a:solidFill>
+                  <a:srgbClr val="0078D4"/>
                 </a:solidFill>
                 <a:latin typeface="Microsoft YaHei"/>
               </a:rPr>
@@ -6033,8 +6258,8 @@
         </p:nvSpPr>
         <p:spPr>
           <a:xfrm>
-            <a:off x="502920" y="1115568"/>
-            <a:ext cx="8138159" cy="9525"/>
+            <a:off x="457200" y="1060704"/>
+            <a:ext cx="8229600" cy="9525"/>
           </a:xfrm>
           <a:prstGeom prst="rect">
             <a:avLst/>
@@ -6076,8 +6301,8 @@
         </p:nvSpPr>
         <p:spPr>
           <a:xfrm>
-            <a:off x="2057400" y="1207008"/>
-            <a:ext cx="2148839" cy="256032"/>
+            <a:off x="2011680" y="1152144"/>
+            <a:ext cx="2179320" cy="256032"/>
           </a:xfrm>
           <a:prstGeom prst="roundRect">
             <a:avLst/>
@@ -6106,7 +6331,7 @@
           </a:fontRef>
         </p:style>
         <p:txBody>
-          <a:bodyPr rtlCol="0" anchor="ctr" wrap="square" tIns="36576" bIns="18288"/>
+          <a:bodyPr rtlCol="0" anchor="ctr" wrap="square" tIns="36576"/>
           <a:lstStyle/>
           <a:p>
             <a:pPr algn="ctr"/>
@@ -6130,18 +6355,18 @@
         </p:nvSpPr>
         <p:spPr>
           <a:xfrm>
-            <a:off x="4251959" y="1207008"/>
-            <a:ext cx="2148839" cy="256032"/>
+            <a:off x="4236720" y="1152144"/>
+            <a:ext cx="2179320" cy="256032"/>
           </a:xfrm>
           <a:prstGeom prst="roundRect">
             <a:avLst/>
           </a:prstGeom>
           <a:solidFill>
-            <a:srgbClr val="009CDE"/>
+            <a:srgbClr val="0078D4"/>
           </a:solidFill>
           <a:ln w="12700">
             <a:solidFill>
-              <a:srgbClr val="009CDE"/>
+              <a:srgbClr val="0078D4"/>
             </a:solidFill>
           </a:ln>
         </p:spPr>
@@ -6160,7 +6385,7 @@
           </a:fontRef>
         </p:style>
         <p:txBody>
-          <a:bodyPr rtlCol="0" anchor="ctr" wrap="square" tIns="36576" bIns="18288"/>
+          <a:bodyPr rtlCol="0" anchor="ctr" wrap="square" tIns="36576"/>
           <a:lstStyle/>
           <a:p>
             <a:pPr algn="ctr"/>
@@ -6184,8 +6409,8 @@
         </p:nvSpPr>
         <p:spPr>
           <a:xfrm>
-            <a:off x="6446519" y="1207008"/>
-            <a:ext cx="2148839" cy="256032"/>
+            <a:off x="6461760" y="1152144"/>
+            <a:ext cx="2179320" cy="256032"/>
           </a:xfrm>
           <a:prstGeom prst="roundRect">
             <a:avLst/>
@@ -6214,7 +6439,7 @@
           </a:fontRef>
         </p:style>
         <p:txBody>
-          <a:bodyPr rtlCol="0" anchor="ctr" wrap="square" tIns="36576" bIns="18288"/>
+          <a:bodyPr rtlCol="0" anchor="ctr" wrap="square" tIns="36576"/>
           <a:lstStyle/>
           <a:p>
             <a:pPr algn="ctr"/>
@@ -6238,8 +6463,8 @@
         </p:nvSpPr>
         <p:spPr>
           <a:xfrm>
-            <a:off x="502920" y="1499616"/>
-            <a:ext cx="1508760" cy="416966"/>
+            <a:off x="457200" y="1444752"/>
+            <a:ext cx="1508760" cy="437083"/>
           </a:xfrm>
           <a:prstGeom prst="roundRect">
             <a:avLst/>
@@ -6268,14 +6493,14 @@
           </a:fontRef>
         </p:style>
         <p:txBody>
-          <a:bodyPr rtlCol="0" anchor="ctr" wrap="square" tIns="36576" bIns="18288" lIns="54864" rIns="54864"/>
+          <a:bodyPr rtlCol="0" anchor="ctr" wrap="square" tIns="36576" lIns="54864" rIns="54864"/>
           <a:lstStyle/>
           <a:p>
             <a:pPr algn="ctr"/>
             <a:r>
               <a:rPr sz="750" b="1">
                 <a:solidFill>
-                  <a:srgbClr val="005A9C"/>
+                  <a:srgbClr val="0078D4"/>
                 </a:solidFill>
                 <a:latin typeface="Georgia"/>
               </a:rPr>
@@ -6304,8 +6529,8 @@
         </p:nvSpPr>
         <p:spPr>
           <a:xfrm>
-            <a:off x="2057400" y="1499616"/>
-            <a:ext cx="2148839" cy="416966"/>
+            <a:off x="2011680" y="1444752"/>
+            <a:ext cx="2179320" cy="437083"/>
           </a:xfrm>
           <a:prstGeom prst="roundRect">
             <a:avLst/>
@@ -6334,7 +6559,7 @@
           </a:fontRef>
         </p:style>
         <p:txBody>
-          <a:bodyPr rtlCol="0" anchor="ctr" wrap="square" tIns="36576" bIns="18288" lIns="54864" rIns="54864"/>
+          <a:bodyPr rtlCol="0" anchor="ctr" wrap="square" tIns="36576" lIns="54864" rIns="54864"/>
           <a:lstStyle/>
           <a:p>
             <a:pPr algn="ctr"/>
@@ -6370,18 +6595,18 @@
         </p:nvSpPr>
         <p:spPr>
           <a:xfrm>
-            <a:off x="4251959" y="1499616"/>
-            <a:ext cx="2148839" cy="416966"/>
+            <a:off x="4236720" y="1444752"/>
+            <a:ext cx="2179320" cy="437083"/>
           </a:xfrm>
           <a:prstGeom prst="roundRect">
             <a:avLst/>
           </a:prstGeom>
           <a:solidFill>
-            <a:srgbClr val="EAF4FB"/>
+            <a:srgbClr val="EBF5FF"/>
           </a:solidFill>
           <a:ln w="12700">
             <a:solidFill>
-              <a:srgbClr val="009CDE"/>
+              <a:srgbClr val="0078D4"/>
             </a:solidFill>
           </a:ln>
         </p:spPr>
@@ -6400,7 +6625,7 @@
           </a:fontRef>
         </p:style>
         <p:txBody>
-          <a:bodyPr rtlCol="0" anchor="ctr" wrap="square" tIns="36576" bIns="18288" lIns="54864" rIns="54864"/>
+          <a:bodyPr rtlCol="0" anchor="ctr" wrap="square" tIns="36576" lIns="54864" rIns="54864"/>
           <a:lstStyle/>
           <a:p>
             <a:pPr algn="ctr"/>
@@ -6436,8 +6661,8 @@
         </p:nvSpPr>
         <p:spPr>
           <a:xfrm>
-            <a:off x="6446519" y="1499616"/>
-            <a:ext cx="2148839" cy="416966"/>
+            <a:off x="6461760" y="1444752"/>
+            <a:ext cx="2179320" cy="437083"/>
           </a:xfrm>
           <a:prstGeom prst="roundRect">
             <a:avLst/>
@@ -6466,7 +6691,7 @@
           </a:fontRef>
         </p:style>
         <p:txBody>
-          <a:bodyPr rtlCol="0" anchor="ctr" wrap="square" tIns="36576" bIns="18288" lIns="54864" rIns="54864"/>
+          <a:bodyPr rtlCol="0" anchor="ctr" wrap="square" tIns="36576" lIns="54864" rIns="54864"/>
           <a:lstStyle/>
           <a:p>
             <a:pPr algn="ctr"/>
@@ -6502,8 +6727,8 @@
         </p:nvSpPr>
         <p:spPr>
           <a:xfrm>
-            <a:off x="502920" y="1953158"/>
-            <a:ext cx="1508760" cy="416966"/>
+            <a:off x="457200" y="1918411"/>
+            <a:ext cx="1508760" cy="437083"/>
           </a:xfrm>
           <a:prstGeom prst="roundRect">
             <a:avLst/>
@@ -6532,14 +6757,14 @@
           </a:fontRef>
         </p:style>
         <p:txBody>
-          <a:bodyPr rtlCol="0" anchor="ctr" wrap="square" tIns="36576" bIns="18288" lIns="54864" rIns="54864"/>
+          <a:bodyPr rtlCol="0" anchor="ctr" wrap="square" tIns="36576" lIns="54864" rIns="54864"/>
           <a:lstStyle/>
           <a:p>
             <a:pPr algn="ctr"/>
             <a:r>
               <a:rPr sz="750" b="1">
                 <a:solidFill>
-                  <a:srgbClr val="005A9C"/>
+                  <a:srgbClr val="0078D4"/>
                 </a:solidFill>
                 <a:latin typeface="Georgia"/>
               </a:rPr>
@@ -6568,8 +6793,8 @@
         </p:nvSpPr>
         <p:spPr>
           <a:xfrm>
-            <a:off x="2057400" y="1953158"/>
-            <a:ext cx="2148839" cy="416966"/>
+            <a:off x="2011680" y="1918411"/>
+            <a:ext cx="2179320" cy="437083"/>
           </a:xfrm>
           <a:prstGeom prst="roundRect">
             <a:avLst/>
@@ -6598,7 +6823,7 @@
           </a:fontRef>
         </p:style>
         <p:txBody>
-          <a:bodyPr rtlCol="0" anchor="ctr" wrap="square" tIns="36576" bIns="18288" lIns="54864" rIns="54864"/>
+          <a:bodyPr rtlCol="0" anchor="ctr" wrap="square" tIns="36576" lIns="54864" rIns="54864"/>
           <a:lstStyle/>
           <a:p>
             <a:pPr algn="ctr"/>
@@ -6634,18 +6859,18 @@
         </p:nvSpPr>
         <p:spPr>
           <a:xfrm>
-            <a:off x="4251959" y="1953158"/>
-            <a:ext cx="2148839" cy="416966"/>
+            <a:off x="4236720" y="1918411"/>
+            <a:ext cx="2179320" cy="437083"/>
           </a:xfrm>
           <a:prstGeom prst="roundRect">
             <a:avLst/>
           </a:prstGeom>
           <a:solidFill>
-            <a:srgbClr val="EAF4FB"/>
+            <a:srgbClr val="EBF5FF"/>
           </a:solidFill>
           <a:ln w="12700">
             <a:solidFill>
-              <a:srgbClr val="009CDE"/>
+              <a:srgbClr val="0078D4"/>
             </a:solidFill>
           </a:ln>
         </p:spPr>
@@ -6664,7 +6889,7 @@
           </a:fontRef>
         </p:style>
         <p:txBody>
-          <a:bodyPr rtlCol="0" anchor="ctr" wrap="square" tIns="36576" bIns="18288" lIns="54864" rIns="54864"/>
+          <a:bodyPr rtlCol="0" anchor="ctr" wrap="square" tIns="36576" lIns="54864" rIns="54864"/>
           <a:lstStyle/>
           <a:p>
             <a:pPr algn="ctr"/>
@@ -6700,8 +6925,8 @@
         </p:nvSpPr>
         <p:spPr>
           <a:xfrm>
-            <a:off x="6446519" y="1953158"/>
-            <a:ext cx="2148839" cy="416966"/>
+            <a:off x="6461760" y="1918411"/>
+            <a:ext cx="2179320" cy="437083"/>
           </a:xfrm>
           <a:prstGeom prst="roundRect">
             <a:avLst/>
@@ -6730,7 +6955,7 @@
           </a:fontRef>
         </p:style>
         <p:txBody>
-          <a:bodyPr rtlCol="0" anchor="ctr" wrap="square" tIns="36576" bIns="18288" lIns="54864" rIns="54864"/>
+          <a:bodyPr rtlCol="0" anchor="ctr" wrap="square" tIns="36576" lIns="54864" rIns="54864"/>
           <a:lstStyle/>
           <a:p>
             <a:pPr algn="ctr"/>
@@ -6766,8 +6991,8 @@
         </p:nvSpPr>
         <p:spPr>
           <a:xfrm>
-            <a:off x="502920" y="2406700"/>
-            <a:ext cx="1508760" cy="416966"/>
+            <a:off x="457200" y="2392070"/>
+            <a:ext cx="1508760" cy="437083"/>
           </a:xfrm>
           <a:prstGeom prst="roundRect">
             <a:avLst/>
@@ -6796,14 +7021,14 @@
           </a:fontRef>
         </p:style>
         <p:txBody>
-          <a:bodyPr rtlCol="0" anchor="ctr" wrap="square" tIns="36576" bIns="18288" lIns="54864" rIns="54864"/>
+          <a:bodyPr rtlCol="0" anchor="ctr" wrap="square" tIns="36576" lIns="54864" rIns="54864"/>
           <a:lstStyle/>
           <a:p>
             <a:pPr algn="ctr"/>
             <a:r>
               <a:rPr sz="750" b="1">
                 <a:solidFill>
-                  <a:srgbClr val="005A9C"/>
+                  <a:srgbClr val="0078D4"/>
                 </a:solidFill>
                 <a:latin typeface="Georgia"/>
               </a:rPr>
@@ -6832,8 +7057,8 @@
         </p:nvSpPr>
         <p:spPr>
           <a:xfrm>
-            <a:off x="2057400" y="2406700"/>
-            <a:ext cx="2148839" cy="416966"/>
+            <a:off x="2011680" y="2392070"/>
+            <a:ext cx="2179320" cy="437083"/>
           </a:xfrm>
           <a:prstGeom prst="roundRect">
             <a:avLst/>
@@ -6862,7 +7087,7 @@
           </a:fontRef>
         </p:style>
         <p:txBody>
-          <a:bodyPr rtlCol="0" anchor="ctr" wrap="square" tIns="36576" bIns="18288" lIns="54864" rIns="54864"/>
+          <a:bodyPr rtlCol="0" anchor="ctr" wrap="square" tIns="36576" lIns="54864" rIns="54864"/>
           <a:lstStyle/>
           <a:p>
             <a:pPr algn="ctr"/>
@@ -6898,18 +7123,18 @@
         </p:nvSpPr>
         <p:spPr>
           <a:xfrm>
-            <a:off x="4251959" y="2406700"/>
-            <a:ext cx="2148839" cy="416966"/>
+            <a:off x="4236720" y="2392070"/>
+            <a:ext cx="2179320" cy="437083"/>
           </a:xfrm>
           <a:prstGeom prst="roundRect">
             <a:avLst/>
           </a:prstGeom>
           <a:solidFill>
-            <a:srgbClr val="EAF4FB"/>
+            <a:srgbClr val="EBF5FF"/>
           </a:solidFill>
           <a:ln w="12700">
             <a:solidFill>
-              <a:srgbClr val="009CDE"/>
+              <a:srgbClr val="0078D4"/>
             </a:solidFill>
           </a:ln>
         </p:spPr>
@@ -6928,7 +7153,7 @@
           </a:fontRef>
         </p:style>
         <p:txBody>
-          <a:bodyPr rtlCol="0" anchor="ctr" wrap="square" tIns="36576" bIns="18288" lIns="54864" rIns="54864"/>
+          <a:bodyPr rtlCol="0" anchor="ctr" wrap="square" tIns="36576" lIns="54864" rIns="54864"/>
           <a:lstStyle/>
           <a:p>
             <a:pPr algn="ctr"/>
@@ -6964,8 +7189,8 @@
         </p:nvSpPr>
         <p:spPr>
           <a:xfrm>
-            <a:off x="6446519" y="2406700"/>
-            <a:ext cx="2148839" cy="416966"/>
+            <a:off x="6461760" y="2392070"/>
+            <a:ext cx="2179320" cy="437083"/>
           </a:xfrm>
           <a:prstGeom prst="roundRect">
             <a:avLst/>
@@ -6994,7 +7219,7 @@
           </a:fontRef>
         </p:style>
         <p:txBody>
-          <a:bodyPr rtlCol="0" anchor="ctr" wrap="square" tIns="36576" bIns="18288" lIns="54864" rIns="54864"/>
+          <a:bodyPr rtlCol="0" anchor="ctr" wrap="square" tIns="36576" lIns="54864" rIns="54864"/>
           <a:lstStyle/>
           <a:p>
             <a:pPr algn="ctr"/>
@@ -7030,8 +7255,8 @@
         </p:nvSpPr>
         <p:spPr>
           <a:xfrm>
-            <a:off x="502920" y="2860243"/>
-            <a:ext cx="1508760" cy="416966"/>
+            <a:off x="457200" y="2865729"/>
+            <a:ext cx="1508760" cy="437083"/>
           </a:xfrm>
           <a:prstGeom prst="roundRect">
             <a:avLst/>
@@ -7060,14 +7285,14 @@
           </a:fontRef>
         </p:style>
         <p:txBody>
-          <a:bodyPr rtlCol="0" anchor="ctr" wrap="square" tIns="36576" bIns="18288" lIns="54864" rIns="54864"/>
+          <a:bodyPr rtlCol="0" anchor="ctr" wrap="square" tIns="36576" lIns="54864" rIns="54864"/>
           <a:lstStyle/>
           <a:p>
             <a:pPr algn="ctr"/>
             <a:r>
               <a:rPr sz="750" b="1">
                 <a:solidFill>
-                  <a:srgbClr val="005A9C"/>
+                  <a:srgbClr val="0078D4"/>
                 </a:solidFill>
                 <a:latin typeface="Georgia"/>
               </a:rPr>
@@ -7096,8 +7321,8 @@
         </p:nvSpPr>
         <p:spPr>
           <a:xfrm>
-            <a:off x="2057400" y="2860243"/>
-            <a:ext cx="2148839" cy="416966"/>
+            <a:off x="2011680" y="2865729"/>
+            <a:ext cx="2179320" cy="437083"/>
           </a:xfrm>
           <a:prstGeom prst="roundRect">
             <a:avLst/>
@@ -7126,7 +7351,7 @@
           </a:fontRef>
         </p:style>
         <p:txBody>
-          <a:bodyPr rtlCol="0" anchor="ctr" wrap="square" tIns="36576" bIns="18288" lIns="54864" rIns="54864"/>
+          <a:bodyPr rtlCol="0" anchor="ctr" wrap="square" tIns="36576" lIns="54864" rIns="54864"/>
           <a:lstStyle/>
           <a:p>
             <a:pPr algn="ctr"/>
@@ -7162,18 +7387,18 @@
         </p:nvSpPr>
         <p:spPr>
           <a:xfrm>
-            <a:off x="4251959" y="2860243"/>
-            <a:ext cx="2148839" cy="416966"/>
+            <a:off x="4236720" y="2865729"/>
+            <a:ext cx="2179320" cy="437083"/>
           </a:xfrm>
           <a:prstGeom prst="roundRect">
             <a:avLst/>
           </a:prstGeom>
           <a:solidFill>
-            <a:srgbClr val="EAF4FB"/>
+            <a:srgbClr val="EBF5FF"/>
           </a:solidFill>
           <a:ln w="12700">
             <a:solidFill>
-              <a:srgbClr val="009CDE"/>
+              <a:srgbClr val="0078D4"/>
             </a:solidFill>
           </a:ln>
         </p:spPr>
@@ -7192,7 +7417,7 @@
           </a:fontRef>
         </p:style>
         <p:txBody>
-          <a:bodyPr rtlCol="0" anchor="ctr" wrap="square" tIns="36576" bIns="18288" lIns="54864" rIns="54864"/>
+          <a:bodyPr rtlCol="0" anchor="ctr" wrap="square" tIns="36576" lIns="54864" rIns="54864"/>
           <a:lstStyle/>
           <a:p>
             <a:pPr algn="ctr"/>
@@ -7228,8 +7453,8 @@
         </p:nvSpPr>
         <p:spPr>
           <a:xfrm>
-            <a:off x="6446519" y="2860243"/>
-            <a:ext cx="2148839" cy="416966"/>
+            <a:off x="6461760" y="2865729"/>
+            <a:ext cx="2179320" cy="437083"/>
           </a:xfrm>
           <a:prstGeom prst="roundRect">
             <a:avLst/>
@@ -7258,7 +7483,7 @@
           </a:fontRef>
         </p:style>
         <p:txBody>
-          <a:bodyPr rtlCol="0" anchor="ctr" wrap="square" tIns="36576" bIns="18288" lIns="54864" rIns="54864"/>
+          <a:bodyPr rtlCol="0" anchor="ctr" wrap="square" tIns="36576" lIns="54864" rIns="54864"/>
           <a:lstStyle/>
           <a:p>
             <a:pPr algn="ctr"/>
@@ -7294,8 +7519,8 @@
         </p:nvSpPr>
         <p:spPr>
           <a:xfrm>
-            <a:off x="502920" y="3313785"/>
-            <a:ext cx="1508760" cy="416966"/>
+            <a:off x="457200" y="3339388"/>
+            <a:ext cx="1508760" cy="437083"/>
           </a:xfrm>
           <a:prstGeom prst="roundRect">
             <a:avLst/>
@@ -7324,14 +7549,14 @@
           </a:fontRef>
         </p:style>
         <p:txBody>
-          <a:bodyPr rtlCol="0" anchor="ctr" wrap="square" tIns="36576" bIns="18288" lIns="54864" rIns="54864"/>
+          <a:bodyPr rtlCol="0" anchor="ctr" wrap="square" tIns="36576" lIns="54864" rIns="54864"/>
           <a:lstStyle/>
           <a:p>
             <a:pPr algn="ctr"/>
             <a:r>
               <a:rPr sz="750" b="1">
                 <a:solidFill>
-                  <a:srgbClr val="005A9C"/>
+                  <a:srgbClr val="0078D4"/>
                 </a:solidFill>
                 <a:latin typeface="Georgia"/>
               </a:rPr>
@@ -7360,8 +7585,8 @@
         </p:nvSpPr>
         <p:spPr>
           <a:xfrm>
-            <a:off x="2057400" y="3313785"/>
-            <a:ext cx="2148839" cy="416966"/>
+            <a:off x="2011680" y="3339388"/>
+            <a:ext cx="2179320" cy="437083"/>
           </a:xfrm>
           <a:prstGeom prst="roundRect">
             <a:avLst/>
@@ -7390,7 +7615,7 @@
           </a:fontRef>
         </p:style>
         <p:txBody>
-          <a:bodyPr rtlCol="0" anchor="ctr" wrap="square" tIns="36576" bIns="18288" lIns="54864" rIns="54864"/>
+          <a:bodyPr rtlCol="0" anchor="ctr" wrap="square" tIns="36576" lIns="54864" rIns="54864"/>
           <a:lstStyle/>
           <a:p>
             <a:pPr algn="ctr"/>
@@ -7426,18 +7651,18 @@
         </p:nvSpPr>
         <p:spPr>
           <a:xfrm>
-            <a:off x="4251959" y="3313785"/>
-            <a:ext cx="2148839" cy="416966"/>
+            <a:off x="4236720" y="3339388"/>
+            <a:ext cx="2179320" cy="437083"/>
           </a:xfrm>
           <a:prstGeom prst="roundRect">
             <a:avLst/>
           </a:prstGeom>
           <a:solidFill>
-            <a:srgbClr val="EAF4FB"/>
+            <a:srgbClr val="EBF5FF"/>
           </a:solidFill>
           <a:ln w="12700">
             <a:solidFill>
-              <a:srgbClr val="009CDE"/>
+              <a:srgbClr val="0078D4"/>
             </a:solidFill>
           </a:ln>
         </p:spPr>
@@ -7456,7 +7681,7 @@
           </a:fontRef>
         </p:style>
         <p:txBody>
-          <a:bodyPr rtlCol="0" anchor="ctr" wrap="square" tIns="36576" bIns="18288" lIns="54864" rIns="54864"/>
+          <a:bodyPr rtlCol="0" anchor="ctr" wrap="square" tIns="36576" lIns="54864" rIns="54864"/>
           <a:lstStyle/>
           <a:p>
             <a:pPr algn="ctr"/>
@@ -7492,8 +7717,8 @@
         </p:nvSpPr>
         <p:spPr>
           <a:xfrm>
-            <a:off x="6446519" y="3313785"/>
-            <a:ext cx="2148839" cy="416966"/>
+            <a:off x="6461760" y="3339388"/>
+            <a:ext cx="2179320" cy="437083"/>
           </a:xfrm>
           <a:prstGeom prst="roundRect">
             <a:avLst/>
@@ -7522,7 +7747,7 @@
           </a:fontRef>
         </p:style>
         <p:txBody>
-          <a:bodyPr rtlCol="0" anchor="ctr" wrap="square" tIns="36576" bIns="18288" lIns="54864" rIns="54864"/>
+          <a:bodyPr rtlCol="0" anchor="ctr" wrap="square" tIns="36576" lIns="54864" rIns="54864"/>
           <a:lstStyle/>
           <a:p>
             <a:pPr algn="ctr"/>
@@ -7558,18 +7783,18 @@
         </p:nvSpPr>
         <p:spPr>
           <a:xfrm>
-            <a:off x="502920" y="3803904"/>
-            <a:ext cx="4882895" cy="457200"/>
+            <a:off x="457200" y="3849623"/>
+            <a:ext cx="4937759" cy="411480"/>
           </a:xfrm>
           <a:prstGeom prst="roundRect">
             <a:avLst/>
           </a:prstGeom>
           <a:solidFill>
-            <a:srgbClr val="EAF4FB"/>
+            <a:srgbClr val="EBF5FF"/>
           </a:solidFill>
           <a:ln w="12700">
             <a:solidFill>
-              <a:srgbClr val="009CDE"/>
+              <a:srgbClr val="0078D4"/>
             </a:solidFill>
           </a:ln>
         </p:spPr>
@@ -7595,7 +7820,7 @@
             <a:r>
               <a:rPr sz="800" b="1">
                 <a:solidFill>
-                  <a:srgbClr val="005A9C"/>
+                  <a:srgbClr val="0078D4"/>
                 </a:solidFill>
                 <a:latin typeface="Microsoft YaHei"/>
               </a:rPr>
@@ -7622,8 +7847,8 @@
         </p:nvSpPr>
         <p:spPr>
           <a:xfrm>
-            <a:off x="5495543" y="3803904"/>
-            <a:ext cx="3145535" cy="457200"/>
+            <a:off x="5504688" y="3849623"/>
+            <a:ext cx="3182112" cy="411480"/>
           </a:xfrm>
           <a:prstGeom prst="roundRect">
             <a:avLst/>
@@ -7704,8 +7929,8 @@
         </p:nvSpPr>
         <p:spPr>
           <a:xfrm>
-            <a:off x="502920" y="256032"/>
-            <a:ext cx="8138159" cy="164592"/>
+            <a:off x="457200" y="237744"/>
+            <a:ext cx="8229600" cy="164592"/>
           </a:xfrm>
           <a:prstGeom prst="rect">
             <a:avLst/>
@@ -7719,7 +7944,7 @@
           <a:lstStyle/>
           <a:p>
             <a:r>
-              <a:rPr sz="750" b="0">
+              <a:rPr sz="750">
                 <a:solidFill>
                   <a:srgbClr val="64748B"/>
                 </a:solidFill>
@@ -7738,8 +7963,8 @@
         </p:nvSpPr>
         <p:spPr>
           <a:xfrm>
-            <a:off x="502920" y="448056"/>
-            <a:ext cx="8138159" cy="347472"/>
+            <a:off x="457200" y="420624"/>
+            <a:ext cx="8229600" cy="329184"/>
           </a:xfrm>
           <a:prstGeom prst="rect">
             <a:avLst/>
@@ -7753,7 +7978,7 @@
           <a:lstStyle/>
           <a:p>
             <a:r>
-              <a:rPr sz="1500" b="1">
+              <a:rPr sz="1450" b="1">
                 <a:solidFill>
                   <a:srgbClr val="0F172A"/>
                 </a:solidFill>
@@ -7772,8 +7997,8 @@
         </p:nvSpPr>
         <p:spPr>
           <a:xfrm>
-            <a:off x="502920" y="822960"/>
-            <a:ext cx="8138159" cy="256032"/>
+            <a:off x="457200" y="768096"/>
+            <a:ext cx="8229600" cy="256032"/>
           </a:xfrm>
           <a:prstGeom prst="rect">
             <a:avLst/>
@@ -7787,9 +8012,9 @@
           <a:lstStyle/>
           <a:p>
             <a:r>
-              <a:rPr sz="1050" b="0">
-                <a:solidFill>
-                  <a:srgbClr val="005A9C"/>
+              <a:rPr sz="1000" b="0">
+                <a:solidFill>
+                  <a:srgbClr val="0078D4"/>
                 </a:solidFill>
                 <a:latin typeface="Microsoft YaHei"/>
               </a:rPr>
@@ -7806,8 +8031,8 @@
         </p:nvSpPr>
         <p:spPr>
           <a:xfrm>
-            <a:off x="502920" y="1115568"/>
-            <a:ext cx="8138159" cy="9525"/>
+            <a:off x="457200" y="1060704"/>
+            <a:ext cx="8229600" cy="9525"/>
           </a:xfrm>
           <a:prstGeom prst="rect">
             <a:avLst/>
@@ -7849,8 +8074,8 @@
         </p:nvSpPr>
         <p:spPr>
           <a:xfrm>
-            <a:off x="502920" y="1207008"/>
-            <a:ext cx="1931669" cy="1691640"/>
+            <a:off x="457200" y="1152144"/>
+            <a:ext cx="1954530" cy="1691640"/>
           </a:xfrm>
           <a:prstGeom prst="roundRect">
             <a:avLst/>
@@ -7860,7 +8085,7 @@
           </a:solidFill>
           <a:ln w="12700">
             <a:solidFill>
-              <a:srgbClr val="E2E8F0"/>
+              <a:srgbClr val="CBD5E1"/>
             </a:solidFill>
           </a:ln>
         </p:spPr>
@@ -7886,7 +8111,7 @@
             <a:r>
               <a:rPr sz="850" b="1">
                 <a:solidFill>
-                  <a:srgbClr val="005A9C"/>
+                  <a:srgbClr val="0078D4"/>
                 </a:solidFill>
                 <a:latin typeface="Georgia"/>
               </a:rPr>
@@ -7983,18 +8208,18 @@
         </p:nvSpPr>
         <p:spPr>
           <a:xfrm>
-            <a:off x="2571750" y="1207008"/>
-            <a:ext cx="1931669" cy="1691640"/>
+            <a:off x="2548890" y="1152144"/>
+            <a:ext cx="1954530" cy="1691640"/>
           </a:xfrm>
           <a:prstGeom prst="roundRect">
             <a:avLst/>
           </a:prstGeom>
           <a:solidFill>
-            <a:srgbClr val="EAF4FB"/>
+            <a:srgbClr val="EBF5FF"/>
           </a:solidFill>
           <a:ln w="19050">
             <a:solidFill>
-              <a:srgbClr val="009CDE"/>
+              <a:srgbClr val="0078D4"/>
             </a:solidFill>
           </a:ln>
         </p:spPr>
@@ -8020,7 +8245,7 @@
             <a:r>
               <a:rPr sz="850" b="1">
                 <a:solidFill>
-                  <a:srgbClr val="005A9C"/>
+                  <a:srgbClr val="0078D4"/>
                 </a:solidFill>
                 <a:latin typeface="Georgia"/>
               </a:rPr>
@@ -8052,7 +8277,7 @@
             <a:r>
               <a:rPr sz="650">
                 <a:solidFill>
-                  <a:srgbClr val="005A9C"/>
+                  <a:srgbClr val="0078D4"/>
                 </a:solidFill>
                 <a:latin typeface="Consolas"/>
               </a:rPr>
@@ -8117,8 +8342,8 @@
         </p:nvSpPr>
         <p:spPr>
           <a:xfrm>
-            <a:off x="4640579" y="1207008"/>
-            <a:ext cx="1931669" cy="1691640"/>
+            <a:off x="4640580" y="1152144"/>
+            <a:ext cx="1954530" cy="1691640"/>
           </a:xfrm>
           <a:prstGeom prst="roundRect">
             <a:avLst/>
@@ -8128,7 +8353,7 @@
           </a:solidFill>
           <a:ln w="12700">
             <a:solidFill>
-              <a:srgbClr val="E2E8F0"/>
+              <a:srgbClr val="CBD5E1"/>
             </a:solidFill>
           </a:ln>
         </p:spPr>
@@ -8154,7 +8379,7 @@
             <a:r>
               <a:rPr sz="850" b="1">
                 <a:solidFill>
-                  <a:srgbClr val="005A9C"/>
+                  <a:srgbClr val="0078D4"/>
                 </a:solidFill>
                 <a:latin typeface="Georgia"/>
               </a:rPr>
@@ -8251,8 +8476,8 @@
         </p:nvSpPr>
         <p:spPr>
           <a:xfrm>
-            <a:off x="6709409" y="1207008"/>
-            <a:ext cx="1931669" cy="1691640"/>
+            <a:off x="6732270" y="1152144"/>
+            <a:ext cx="1954530" cy="1691640"/>
           </a:xfrm>
           <a:prstGeom prst="roundRect">
             <a:avLst/>
@@ -8262,7 +8487,7 @@
           </a:solidFill>
           <a:ln w="12700">
             <a:solidFill>
-              <a:srgbClr val="E2E8F0"/>
+              <a:srgbClr val="CBD5E1"/>
             </a:solidFill>
           </a:ln>
         </p:spPr>
@@ -8288,7 +8513,7 @@
             <a:r>
               <a:rPr sz="850" b="1">
                 <a:solidFill>
-                  <a:srgbClr val="005A9C"/>
+                  <a:srgbClr val="0078D4"/>
                 </a:solidFill>
                 <a:latin typeface="Georgia"/>
               </a:rPr>
@@ -8385,8 +8610,8 @@
         </p:nvSpPr>
         <p:spPr>
           <a:xfrm>
-            <a:off x="502920" y="3035808"/>
-            <a:ext cx="2590799" cy="1188720"/>
+            <a:off x="457200" y="2980944"/>
+            <a:ext cx="2621280" cy="1188720"/>
           </a:xfrm>
           <a:prstGeom prst="roundRect">
             <a:avLst/>
@@ -8396,7 +8621,7 @@
           </a:solidFill>
           <a:ln w="9525">
             <a:solidFill>
-              <a:srgbClr val="E2E8F0"/>
+              <a:srgbClr val="CBD5E1"/>
             </a:solidFill>
           </a:ln>
         </p:spPr>
@@ -8415,18 +8640,18 @@
           </a:fontRef>
         </p:style>
         <p:txBody>
-          <a:bodyPr rtlCol="0" anchor="ctr" wrap="square" tIns="73152" bIns="54864"/>
+          <a:bodyPr rtlCol="0" anchor="ctr" wrap="square" tIns="73152"/>
           <a:lstStyle/>
           <a:p>
             <a:pPr algn="ctr"/>
             <a:r>
-              <a:rPr sz="2000" b="1">
-                <a:solidFill>
-                  <a:srgbClr val="009CDE"/>
+              <a:rPr sz="1800" b="1">
+                <a:solidFill>
+                  <a:srgbClr val="0078D4"/>
                 </a:solidFill>
                 <a:latin typeface="Georgia"/>
               </a:rPr>
-              <a:t>15 分钟
+              <a:t>⚡ 15 分钟
 </a:t>
             </a:r>
           </a:p>
@@ -8460,7 +8685,7 @@
                 </a:solidFill>
                 <a:latin typeface="Microsoft YaHei"/>
               </a:rPr>
-              <a:t>从传统 T+1 日级批处理跨越至分钟级增量可用，全面支撑实时运营决策。</a:t>
+              <a:t>从传统 T+1 日级批处理跨越至分钟级增量可用，全面支撑业务敏捷运营与实时分析。</a:t>
             </a:r>
           </a:p>
         </p:txBody>
@@ -8473,8 +8698,8 @@
         </p:nvSpPr>
         <p:spPr>
           <a:xfrm>
-            <a:off x="3276599" y="3035808"/>
-            <a:ext cx="2590799" cy="1188720"/>
+            <a:off x="3261360" y="2980944"/>
+            <a:ext cx="2621280" cy="1188720"/>
           </a:xfrm>
           <a:prstGeom prst="roundRect">
             <a:avLst/>
@@ -8484,7 +8709,7 @@
           </a:solidFill>
           <a:ln w="9525">
             <a:solidFill>
-              <a:srgbClr val="E2E8F0"/>
+              <a:srgbClr val="CBD5E1"/>
             </a:solidFill>
           </a:ln>
         </p:spPr>
@@ -8503,18 +8728,18 @@
           </a:fontRef>
         </p:style>
         <p:txBody>
-          <a:bodyPr rtlCol="0" anchor="ctr" wrap="square" tIns="73152" bIns="54864"/>
+          <a:bodyPr rtlCol="0" anchor="ctr" wrap="square" tIns="73152"/>
           <a:lstStyle/>
           <a:p>
             <a:pPr algn="ctr"/>
             <a:r>
-              <a:rPr sz="2000" b="1">
-                <a:solidFill>
-                  <a:srgbClr val="009CDE"/>
+              <a:rPr sz="1800" b="1">
+                <a:solidFill>
+                  <a:srgbClr val="0078D4"/>
                 </a:solidFill>
                 <a:latin typeface="Georgia"/>
               </a:rPr>
-              <a:t>35%
+              <a:t>💰 -35%
 </a:t>
             </a:r>
           </a:p>
@@ -8548,7 +8773,7 @@
                 </a:solidFill>
                 <a:latin typeface="Microsoft YaHei"/>
               </a:rPr>
-              <a:t>存算分离架构 + Serverless 弹性缩容归零，杜绝常驻空转算力开销。</a:t>
+              <a:t>存算分离架构 + Serverless 弹性缩容归零，彻底杜绝常驻空转算力与冗余存储浪费。</a:t>
             </a:r>
           </a:p>
         </p:txBody>
@@ -8561,8 +8786,8 @@
         </p:nvSpPr>
         <p:spPr>
           <a:xfrm>
-            <a:off x="6050279" y="3035808"/>
-            <a:ext cx="2590799" cy="1188720"/>
+            <a:off x="6065520" y="2980944"/>
+            <a:ext cx="2621280" cy="1188720"/>
           </a:xfrm>
           <a:prstGeom prst="roundRect">
             <a:avLst/>
@@ -8572,7 +8797,7 @@
           </a:solidFill>
           <a:ln w="9525">
             <a:solidFill>
-              <a:srgbClr val="E2E8F0"/>
+              <a:srgbClr val="CBD5E1"/>
             </a:solidFill>
           </a:ln>
         </p:spPr>
@@ -8591,18 +8816,18 @@
           </a:fontRef>
         </p:style>
         <p:txBody>
-          <a:bodyPr rtlCol="0" anchor="ctr" wrap="square" tIns="73152" bIns="54864"/>
+          <a:bodyPr rtlCol="0" anchor="ctr" wrap="square" tIns="73152"/>
           <a:lstStyle/>
           <a:p>
             <a:pPr algn="ctr"/>
             <a:r>
-              <a:rPr sz="2000" b="1">
-                <a:solidFill>
-                  <a:srgbClr val="009CDE"/>
+              <a:rPr sz="1800" b="1">
+                <a:solidFill>
+                  <a:srgbClr val="0078D4"/>
                 </a:solidFill>
                 <a:latin typeface="Georgia"/>
               </a:rPr>
-              <a:t>70%
+              <a:t>📉 -70%
 </a:t>
             </a:r>
           </a:p>
@@ -8636,7 +8861,7 @@
                 </a:solidFill>
                 <a:latin typeface="Microsoft YaHei"/>
               </a:rPr>
-              <a:t>端到端自动化管道 + 统一元数据治理 (Purview)，大幅减少数据对账工作量。</a:t>
+              <a:t>端到端自动化管道 + 统一元数据治理 (Purview)，大幅减少数据对账与链路排查负担。</a:t>
             </a:r>
           </a:p>
         </p:txBody>
@@ -8649,18 +8874,18 @@
         </p:nvSpPr>
         <p:spPr>
           <a:xfrm>
-            <a:off x="502920" y="4462272"/>
-            <a:ext cx="8138159" cy="384048"/>
+            <a:off x="457200" y="4462272"/>
+            <a:ext cx="8229600" cy="384048"/>
           </a:xfrm>
           <a:prstGeom prst="roundRect">
             <a:avLst/>
           </a:prstGeom>
           <a:solidFill>
-            <a:srgbClr val="EAF4FB"/>
+            <a:srgbClr val="EBF5FF"/>
           </a:solidFill>
           <a:ln w="12700">
             <a:solidFill>
-              <a:srgbClr val="009CDE"/>
+              <a:srgbClr val="0078D4"/>
             </a:solidFill>
           </a:ln>
         </p:spPr>
@@ -8686,1093 +8911,20 @@
             <a:r>
               <a:rPr sz="850" b="1">
                 <a:solidFill>
-                  <a:srgbClr val="005A9C"/>
+                  <a:srgbClr val="0078D4"/>
                 </a:solidFill>
                 <a:latin typeface="Microsoft YaHei"/>
               </a:rPr>
               <a:t>【流程收益结论】 </a:t>
             </a:r>
             <a:r>
-              <a:rPr sz="850" b="0">
+              <a:rPr sz="800">
                 <a:solidFill>
                   <a:srgbClr val="0F172A"/>
                 </a:solidFill>
                 <a:latin typeface="Microsoft YaHei"/>
               </a:rPr>
               <a:t>以流批一体闭环代替散落手工脚本，打通从源端感知到业务报表毫秒呈现的全流程，兼备敏捷度、高可靠性与合规性。</a:t>
-            </a:r>
-          </a:p>
-        </p:txBody>
-      </p:sp>
-    </p:spTree>
-  </p:cSld>
-  <p:clrMapOvr>
-    <a:masterClrMapping/>
-  </p:clrMapOvr>
-</p:sld>
-</file>
-
-<file path=ppt/slides/slide6.xml><?xml version="1.0" encoding="utf-8"?>
-<p:sld xmlns:a="http://schemas.openxmlformats.org/drawingml/2006/main" xmlns:p="http://schemas.openxmlformats.org/presentationml/2006/main" xmlns:r="http://schemas.openxmlformats.org/officeDocument/2006/relationships">
-  <p:cSld>
-    <p:spTree>
-      <p:nvGrpSpPr>
-        <p:cNvPr id="1" name=""/>
-        <p:cNvGrpSpPr/>
-        <p:nvPr/>
-      </p:nvGrpSpPr>
-      <p:grpSpPr/>
-      <p:sp>
-        <p:nvSpPr>
-          <p:cNvPr id="2" name="TextBox 1"/>
-          <p:cNvSpPr txBox="1"/>
-          <p:nvPr/>
-        </p:nvSpPr>
-        <p:spPr>
-          <a:xfrm>
-            <a:off x="502920" y="256032"/>
-            <a:ext cx="8138159" cy="164592"/>
-          </a:xfrm>
-          <a:prstGeom prst="rect">
-            <a:avLst/>
-          </a:prstGeom>
-          <a:noFill/>
-        </p:spPr>
-        <p:txBody>
-          <a:bodyPr wrap="square" tIns="0" bIns="0" lIns="0" rIns="0">
-            <a:spAutoFit/>
-          </a:bodyPr>
-          <a:lstStyle/>
-          <a:p>
-            <a:r>
-              <a:rPr sz="750" b="0">
-                <a:solidFill>
-                  <a:srgbClr val="64748B"/>
-                </a:solidFill>
-                <a:latin typeface="Georgia"/>
-              </a:rPr>
-              <a:t>AZURE DATA PLATFORM IMPLEMENTATION | PROJECT ROADMAP</a:t>
-            </a:r>
-          </a:p>
-        </p:txBody>
-      </p:sp>
-      <p:sp>
-        <p:nvSpPr>
-          <p:cNvPr id="3" name="TextBox 2"/>
-          <p:cNvSpPr txBox="1"/>
-          <p:nvPr/>
-        </p:nvSpPr>
-        <p:spPr>
-          <a:xfrm>
-            <a:off x="502920" y="448056"/>
-            <a:ext cx="8138159" cy="347472"/>
-          </a:xfrm>
-          <a:prstGeom prst="rect">
-            <a:avLst/>
-          </a:prstGeom>
-          <a:noFill/>
-        </p:spPr>
-        <p:txBody>
-          <a:bodyPr wrap="square" tIns="0" bIns="0" lIns="0" rIns="0">
-            <a:spAutoFit/>
-          </a:bodyPr>
-          <a:lstStyle/>
-          <a:p>
-            <a:r>
-              <a:rPr sz="1500" b="1">
-                <a:solidFill>
-                  <a:srgbClr val="0F172A"/>
-                </a:solidFill>
-                <a:latin typeface="Georgia"/>
-              </a:rPr>
-              <a:t>实施路线图：10 周搭建高弹性、高治理能力的现代化 Azure 湖仓平台</a:t>
-            </a:r>
-          </a:p>
-        </p:txBody>
-      </p:sp>
-      <p:sp>
-        <p:nvSpPr>
-          <p:cNvPr id="4" name="TextBox 3"/>
-          <p:cNvSpPr txBox="1"/>
-          <p:nvPr/>
-        </p:nvSpPr>
-        <p:spPr>
-          <a:xfrm>
-            <a:off x="502920" y="822960"/>
-            <a:ext cx="8138159" cy="256032"/>
-          </a:xfrm>
-          <a:prstGeom prst="rect">
-            <a:avLst/>
-          </a:prstGeom>
-          <a:noFill/>
-        </p:spPr>
-        <p:txBody>
-          <a:bodyPr wrap="square" tIns="0" bIns="0" lIns="0" rIns="0">
-            <a:spAutoFit/>
-          </a:bodyPr>
-          <a:lstStyle/>
-          <a:p>
-            <a:r>
-              <a:rPr sz="1050" b="0">
-                <a:solidFill>
-                  <a:srgbClr val="005A9C"/>
-                </a:solidFill>
-                <a:latin typeface="Microsoft YaHei"/>
-              </a:rPr>
-              <a:t>遵循敏捷迭代与规范驱动开发原则，前置架构与治理基线，分四阶段稳步实现生产级投产与价值验证。</a:t>
-            </a:r>
-          </a:p>
-        </p:txBody>
-      </p:sp>
-      <p:sp>
-        <p:nvSpPr>
-          <p:cNvPr id="5" name="Rectangle 4"/>
-          <p:cNvSpPr/>
-          <p:nvPr/>
-        </p:nvSpPr>
-        <p:spPr>
-          <a:xfrm>
-            <a:off x="502920" y="1115568"/>
-            <a:ext cx="8138159" cy="9525"/>
-          </a:xfrm>
-          <a:prstGeom prst="rect">
-            <a:avLst/>
-          </a:prstGeom>
-          <a:solidFill>
-            <a:srgbClr val="E2E8F0"/>
-          </a:solidFill>
-          <a:ln>
-            <a:noFill/>
-          </a:ln>
-        </p:spPr>
-        <p:style>
-          <a:lnRef idx="1">
-            <a:schemeClr val="accent1"/>
-          </a:lnRef>
-          <a:fillRef idx="3">
-            <a:schemeClr val="accent1"/>
-          </a:fillRef>
-          <a:effectRef idx="2">
-            <a:schemeClr val="accent1"/>
-          </a:effectRef>
-          <a:fontRef idx="minor">
-            <a:schemeClr val="lt1"/>
-          </a:fontRef>
-        </p:style>
-        <p:txBody>
-          <a:bodyPr rtlCol="0" anchor="ctr"/>
-          <a:lstStyle/>
-          <a:p>
-            <a:pPr algn="ctr"/>
-          </a:p>
-        </p:txBody>
-      </p:sp>
-      <p:sp>
-        <p:nvSpPr>
-          <p:cNvPr id="6" name="Rounded Rectangle 5"/>
-          <p:cNvSpPr/>
-          <p:nvPr/>
-        </p:nvSpPr>
-        <p:spPr>
-          <a:xfrm>
-            <a:off x="502920" y="1207008"/>
-            <a:ext cx="1931669" cy="1645920"/>
-          </a:xfrm>
-          <a:prstGeom prst="roundRect">
-            <a:avLst/>
-          </a:prstGeom>
-          <a:solidFill>
-            <a:srgbClr val="FFFFFF"/>
-          </a:solidFill>
-          <a:ln w="12700">
-            <a:solidFill>
-              <a:srgbClr val="E2E8F0"/>
-            </a:solidFill>
-          </a:ln>
-        </p:spPr>
-        <p:style>
-          <a:lnRef idx="1">
-            <a:schemeClr val="accent1"/>
-          </a:lnRef>
-          <a:fillRef idx="3">
-            <a:schemeClr val="accent1"/>
-          </a:fillRef>
-          <a:effectRef idx="2">
-            <a:schemeClr val="accent1"/>
-          </a:effectRef>
-          <a:fontRef idx="minor">
-            <a:schemeClr val="lt1"/>
-          </a:fontRef>
-        </p:style>
-        <p:txBody>
-          <a:bodyPr rtlCol="0" anchor="ctr" wrap="square" tIns="73152" bIns="54864" lIns="73152" rIns="73152"/>
-          <a:lstStyle/>
-          <a:p>
-            <a:pPr algn="ctr"/>
-            <a:r>
-              <a:rPr sz="850" b="1">
-                <a:solidFill>
-                  <a:srgbClr val="005A9C"/>
-                </a:solidFill>
-                <a:latin typeface="Georgia"/>
-              </a:rPr>
-              <a:t>PHASE 1 ｜ 2 周
-</a:t>
-            </a:r>
-          </a:p>
-          <a:p>
-            <a:r>
-              <a:rPr sz="950" b="1">
-                <a:solidFill>
-                  <a:srgbClr val="0F172A"/>
-                </a:solidFill>
-                <a:latin typeface="Georgia"/>
-              </a:rPr>
-              <a:t>基础设施与安全基线
-</a:t>
-            </a:r>
-          </a:p>
-          <a:p>
-            <a:pPr>
-              <a:spcBef>
-                <a:spcPts val="200"/>
-              </a:spcBef>
-            </a:pPr>
-            <a:r>
-              <a:rPr sz="700">
-                <a:solidFill>
-                  <a:srgbClr val="334155"/>
-                </a:solidFill>
-                <a:latin typeface="Microsoft YaHei"/>
-              </a:rPr>
-              <a:t>• VNet 网络与私有端点 (Private Link) 规划</a:t>
-            </a:r>
-          </a:p>
-          <a:p>
-            <a:pPr>
-              <a:spcBef>
-                <a:spcPts val="200"/>
-              </a:spcBef>
-            </a:pPr>
-            <a:r>
-              <a:rPr sz="700">
-                <a:solidFill>
-                  <a:srgbClr val="334155"/>
-                </a:solidFill>
-                <a:latin typeface="Microsoft YaHei"/>
-              </a:rPr>
-              <a:t>• 部署 ADF、Databricks 与 Synapse 工作区</a:t>
-            </a:r>
-          </a:p>
-          <a:p>
-            <a:pPr>
-              <a:spcBef>
-                <a:spcPts val="200"/>
-              </a:spcBef>
-            </a:pPr>
-            <a:r>
-              <a:rPr sz="700">
-                <a:solidFill>
-                  <a:srgbClr val="334155"/>
-                </a:solidFill>
-                <a:latin typeface="Microsoft YaHei"/>
-              </a:rPr>
-              <a:t>• Key Vault 统一凭据托管与 Entra ID 授权</a:t>
-            </a:r>
-          </a:p>
-          <a:p>
-            <a:pPr>
-              <a:spcBef>
-                <a:spcPts val="400"/>
-              </a:spcBef>
-            </a:pPr>
-            <a:r>
-              <a:rPr sz="650" b="1">
-                <a:solidFill>
-                  <a:srgbClr val="005A9C"/>
-                </a:solidFill>
-                <a:latin typeface="Microsoft YaHei"/>
-              </a:rPr>
-              <a:t>退出标准: </a:t>
-            </a:r>
-            <a:r>
-              <a:rPr sz="650">
-                <a:solidFill>
-                  <a:srgbClr val="64748B"/>
-                </a:solidFill>
-                <a:latin typeface="Microsoft YaHei"/>
-              </a:rPr>
-              <a:t>基础设施自动化部署通过，安全基线评审无阻断</a:t>
-            </a:r>
-          </a:p>
-        </p:txBody>
-      </p:sp>
-      <p:sp>
-        <p:nvSpPr>
-          <p:cNvPr id="7" name="Rounded Rectangle 6"/>
-          <p:cNvSpPr/>
-          <p:nvPr/>
-        </p:nvSpPr>
-        <p:spPr>
-          <a:xfrm>
-            <a:off x="2571750" y="1207008"/>
-            <a:ext cx="1931669" cy="1645920"/>
-          </a:xfrm>
-          <a:prstGeom prst="roundRect">
-            <a:avLst/>
-          </a:prstGeom>
-          <a:solidFill>
-            <a:srgbClr val="EAF4FB"/>
-          </a:solidFill>
-          <a:ln w="19050">
-            <a:solidFill>
-              <a:srgbClr val="009CDE"/>
-            </a:solidFill>
-          </a:ln>
-        </p:spPr>
-        <p:style>
-          <a:lnRef idx="1">
-            <a:schemeClr val="accent1"/>
-          </a:lnRef>
-          <a:fillRef idx="3">
-            <a:schemeClr val="accent1"/>
-          </a:fillRef>
-          <a:effectRef idx="2">
-            <a:schemeClr val="accent1"/>
-          </a:effectRef>
-          <a:fontRef idx="minor">
-            <a:schemeClr val="lt1"/>
-          </a:fontRef>
-        </p:style>
-        <p:txBody>
-          <a:bodyPr rtlCol="0" anchor="ctr" wrap="square" tIns="73152" bIns="54864" lIns="73152" rIns="73152"/>
-          <a:lstStyle/>
-          <a:p>
-            <a:pPr algn="ctr"/>
-            <a:r>
-              <a:rPr sz="850" b="1">
-                <a:solidFill>
-                  <a:srgbClr val="005A9C"/>
-                </a:solidFill>
-                <a:latin typeface="Georgia"/>
-              </a:rPr>
-              <a:t>PHASE 2 ｜ 4 周
-</a:t>
-            </a:r>
-          </a:p>
-          <a:p>
-            <a:r>
-              <a:rPr sz="950" b="1">
-                <a:solidFill>
-                  <a:srgbClr val="0F172A"/>
-                </a:solidFill>
-                <a:latin typeface="Georgia"/>
-              </a:rPr>
-              <a:t>核心流水线与湖仓精炼
-</a:t>
-            </a:r>
-          </a:p>
-          <a:p>
-            <a:pPr>
-              <a:spcBef>
-                <a:spcPts val="200"/>
-              </a:spcBef>
-            </a:pPr>
-            <a:r>
-              <a:rPr sz="700">
-                <a:solidFill>
-                  <a:srgbClr val="334155"/>
-                </a:solidFill>
-                <a:latin typeface="Microsoft YaHei"/>
-              </a:rPr>
-              <a:t>• ADF 首批核心源系统抽取管道调优 (小时级/天级)</a:t>
-            </a:r>
-          </a:p>
-          <a:p>
-            <a:pPr>
-              <a:spcBef>
-                <a:spcPts val="200"/>
-              </a:spcBef>
-            </a:pPr>
-            <a:r>
-              <a:rPr sz="700">
-                <a:solidFill>
-                  <a:srgbClr val="334155"/>
-                </a:solidFill>
-                <a:latin typeface="Microsoft YaHei"/>
-              </a:rPr>
-              <a:t>• 编写 Databricks Auto Loader 与 Bronze/Silver 作业</a:t>
-            </a:r>
-          </a:p>
-          <a:p>
-            <a:pPr>
-              <a:spcBef>
-                <a:spcPts val="200"/>
-              </a:spcBef>
-            </a:pPr>
-            <a:r>
-              <a:rPr sz="700">
-                <a:solidFill>
-                  <a:srgbClr val="334155"/>
-                </a:solidFill>
-                <a:latin typeface="Microsoft YaHei"/>
-              </a:rPr>
-              <a:t>• 建立数据质量校验规则库与监控告警机制</a:t>
-            </a:r>
-          </a:p>
-          <a:p>
-            <a:pPr>
-              <a:spcBef>
-                <a:spcPts val="400"/>
-              </a:spcBef>
-            </a:pPr>
-            <a:r>
-              <a:rPr sz="650" b="1">
-                <a:solidFill>
-                  <a:srgbClr val="005A9C"/>
-                </a:solidFill>
-                <a:latin typeface="Microsoft YaHei"/>
-              </a:rPr>
-              <a:t>退出标准: </a:t>
-            </a:r>
-            <a:r>
-              <a:rPr sz="650">
-                <a:solidFill>
-                  <a:srgbClr val="64748B"/>
-                </a:solidFill>
-                <a:latin typeface="Microsoft YaHei"/>
-              </a:rPr>
-              <a:t>首批核心系统端到端冒烟测试全部通过，吞吐达标</a:t>
-            </a:r>
-          </a:p>
-        </p:txBody>
-      </p:sp>
-      <p:sp>
-        <p:nvSpPr>
-          <p:cNvPr id="8" name="Rounded Rectangle 7"/>
-          <p:cNvSpPr/>
-          <p:nvPr/>
-        </p:nvSpPr>
-        <p:spPr>
-          <a:xfrm>
-            <a:off x="4640579" y="1207008"/>
-            <a:ext cx="1931669" cy="1645920"/>
-          </a:xfrm>
-          <a:prstGeom prst="roundRect">
-            <a:avLst/>
-          </a:prstGeom>
-          <a:solidFill>
-            <a:srgbClr val="FFFFFF"/>
-          </a:solidFill>
-          <a:ln w="12700">
-            <a:solidFill>
-              <a:srgbClr val="E2E8F0"/>
-            </a:solidFill>
-          </a:ln>
-        </p:spPr>
-        <p:style>
-          <a:lnRef idx="1">
-            <a:schemeClr val="accent1"/>
-          </a:lnRef>
-          <a:fillRef idx="3">
-            <a:schemeClr val="accent1"/>
-          </a:fillRef>
-          <a:effectRef idx="2">
-            <a:schemeClr val="accent1"/>
-          </a:effectRef>
-          <a:fontRef idx="minor">
-            <a:schemeClr val="lt1"/>
-          </a:fontRef>
-        </p:style>
-        <p:txBody>
-          <a:bodyPr rtlCol="0" anchor="ctr" wrap="square" tIns="73152" bIns="54864" lIns="73152" rIns="73152"/>
-          <a:lstStyle/>
-          <a:p>
-            <a:pPr algn="ctr"/>
-            <a:r>
-              <a:rPr sz="850" b="1">
-                <a:solidFill>
-                  <a:srgbClr val="005A9C"/>
-                </a:solidFill>
-                <a:latin typeface="Georgia"/>
-              </a:rPr>
-              <a:t>PHASE 3 ｜ 3 周
-</a:t>
-            </a:r>
-          </a:p>
-          <a:p>
-            <a:r>
-              <a:rPr sz="950" b="1">
-                <a:solidFill>
-                  <a:srgbClr val="0F172A"/>
-                </a:solidFill>
-                <a:latin typeface="Georgia"/>
-              </a:rPr>
-              <a:t>数仓建模与 BI 报表集成
-</a:t>
-            </a:r>
-          </a:p>
-          <a:p>
-            <a:pPr>
-              <a:spcBef>
-                <a:spcPts val="200"/>
-              </a:spcBef>
-            </a:pPr>
-            <a:r>
-              <a:rPr sz="700">
-                <a:solidFill>
-                  <a:srgbClr val="334155"/>
-                </a:solidFill>
-                <a:latin typeface="Microsoft YaHei"/>
-              </a:rPr>
-              <a:t>• Synapse 专用 SQL 池星型模型建立 (Fact/Dim)</a:t>
-            </a:r>
-          </a:p>
-          <a:p>
-            <a:pPr>
-              <a:spcBef>
-                <a:spcPts val="200"/>
-              </a:spcBef>
-            </a:pPr>
-            <a:r>
-              <a:rPr sz="700">
-                <a:solidFill>
-                  <a:srgbClr val="334155"/>
-                </a:solidFill>
-                <a:latin typeface="Microsoft YaHei"/>
-              </a:rPr>
-              <a:t>• 调优 PolyBase 高速链路，Gold层加速分发</a:t>
-            </a:r>
-          </a:p>
-          <a:p>
-            <a:pPr>
-              <a:spcBef>
-                <a:spcPts val="200"/>
-              </a:spcBef>
-            </a:pPr>
-            <a:r>
-              <a:rPr sz="700">
-                <a:solidFill>
-                  <a:srgbClr val="334155"/>
-                </a:solidFill>
-                <a:latin typeface="Microsoft YaHei"/>
-              </a:rPr>
-              <a:t>• Power BI 核心管理看板搭建与 DirectLake 性能压测</a:t>
-            </a:r>
-          </a:p>
-          <a:p>
-            <a:pPr>
-              <a:spcBef>
-                <a:spcPts val="400"/>
-              </a:spcBef>
-            </a:pPr>
-            <a:r>
-              <a:rPr sz="650" b="1">
-                <a:solidFill>
-                  <a:srgbClr val="005A9C"/>
-                </a:solidFill>
-                <a:latin typeface="Microsoft YaHei"/>
-              </a:rPr>
-              <a:t>退出标准: </a:t>
-            </a:r>
-            <a:r>
-              <a:rPr sz="650">
-                <a:solidFill>
-                  <a:srgbClr val="64748B"/>
-                </a:solidFill>
-                <a:latin typeface="Microsoft YaHei"/>
-              </a:rPr>
-              <a:t>关键业务用户开展 UAT 验收并签署确认书</a:t>
-            </a:r>
-          </a:p>
-        </p:txBody>
-      </p:sp>
-      <p:sp>
-        <p:nvSpPr>
-          <p:cNvPr id="9" name="Rounded Rectangle 8"/>
-          <p:cNvSpPr/>
-          <p:nvPr/>
-        </p:nvSpPr>
-        <p:spPr>
-          <a:xfrm>
-            <a:off x="6709409" y="1207008"/>
-            <a:ext cx="1931669" cy="1645920"/>
-          </a:xfrm>
-          <a:prstGeom prst="roundRect">
-            <a:avLst/>
-          </a:prstGeom>
-          <a:solidFill>
-            <a:srgbClr val="FFFFFF"/>
-          </a:solidFill>
-          <a:ln w="12700">
-            <a:solidFill>
-              <a:srgbClr val="E2E8F0"/>
-            </a:solidFill>
-          </a:ln>
-        </p:spPr>
-        <p:style>
-          <a:lnRef idx="1">
-            <a:schemeClr val="accent1"/>
-          </a:lnRef>
-          <a:fillRef idx="3">
-            <a:schemeClr val="accent1"/>
-          </a:fillRef>
-          <a:effectRef idx="2">
-            <a:schemeClr val="accent1"/>
-          </a:effectRef>
-          <a:fontRef idx="minor">
-            <a:schemeClr val="lt1"/>
-          </a:fontRef>
-        </p:style>
-        <p:txBody>
-          <a:bodyPr rtlCol="0" anchor="ctr" wrap="square" tIns="73152" bIns="54864" lIns="73152" rIns="73152"/>
-          <a:lstStyle/>
-          <a:p>
-            <a:pPr algn="ctr"/>
-            <a:r>
-              <a:rPr sz="850" b="1">
-                <a:solidFill>
-                  <a:srgbClr val="005A9C"/>
-                </a:solidFill>
-                <a:latin typeface="Georgia"/>
-              </a:rPr>
-              <a:t>PHASE 4 ｜ 1 周
-</a:t>
-            </a:r>
-          </a:p>
-          <a:p>
-            <a:r>
-              <a:rPr sz="950" b="1">
-                <a:solidFill>
-                  <a:srgbClr val="0F172A"/>
-                </a:solidFill>
-                <a:latin typeface="Georgia"/>
-              </a:rPr>
-              <a:t>生产割接与平稳运维交接
-</a:t>
-            </a:r>
-          </a:p>
-          <a:p>
-            <a:pPr>
-              <a:spcBef>
-                <a:spcPts val="200"/>
-              </a:spcBef>
-            </a:pPr>
-            <a:r>
-              <a:rPr sz="700">
-                <a:solidFill>
-                  <a:srgbClr val="334155"/>
-                </a:solidFill>
-                <a:latin typeface="Microsoft YaHei"/>
-              </a:rPr>
-              <a:t>• 生产环境同构部署与网络策略最终放行</a:t>
-            </a:r>
-          </a:p>
-          <a:p>
-            <a:pPr>
-              <a:spcBef>
-                <a:spcPts val="200"/>
-              </a:spcBef>
-            </a:pPr>
-            <a:r>
-              <a:rPr sz="700">
-                <a:solidFill>
-                  <a:srgbClr val="334155"/>
-                </a:solidFill>
-                <a:latin typeface="Microsoft YaHei"/>
-              </a:rPr>
-              <a:t>• 全量历史数据一次性对账核对与增量追平</a:t>
-            </a:r>
-          </a:p>
-          <a:p>
-            <a:pPr>
-              <a:spcBef>
-                <a:spcPts val="200"/>
-              </a:spcBef>
-            </a:pPr>
-            <a:r>
-              <a:rPr sz="700">
-                <a:solidFill>
-                  <a:srgbClr val="334155"/>
-                </a:solidFill>
-                <a:latin typeface="Microsoft YaHei"/>
-              </a:rPr>
-              <a:t>• 上线投产、团队运维赋能培训与平稳交接</a:t>
-            </a:r>
-          </a:p>
-          <a:p>
-            <a:pPr>
-              <a:spcBef>
-                <a:spcPts val="400"/>
-              </a:spcBef>
-            </a:pPr>
-            <a:r>
-              <a:rPr sz="650" b="1">
-                <a:solidFill>
-                  <a:srgbClr val="005A9C"/>
-                </a:solidFill>
-                <a:latin typeface="Microsoft YaHei"/>
-              </a:rPr>
-              <a:t>退出标准: </a:t>
-            </a:r>
-            <a:r>
-              <a:rPr sz="650">
-                <a:solidFill>
-                  <a:srgbClr val="64748B"/>
-                </a:solidFill>
-                <a:latin typeface="Microsoft YaHei"/>
-              </a:rPr>
-              <a:t>生产环境稳定运行 72 小时无重大缺陷，进入维保</a:t>
-            </a:r>
-          </a:p>
-        </p:txBody>
-      </p:sp>
-      <p:sp>
-        <p:nvSpPr>
-          <p:cNvPr id="10" name="Rounded Rectangle 9"/>
-          <p:cNvSpPr/>
-          <p:nvPr/>
-        </p:nvSpPr>
-        <p:spPr>
-          <a:xfrm>
-            <a:off x="502920" y="2990088"/>
-            <a:ext cx="4720132" cy="1234440"/>
-          </a:xfrm>
-          <a:prstGeom prst="roundRect">
-            <a:avLst/>
-          </a:prstGeom>
-          <a:solidFill>
-            <a:srgbClr val="FFFFFF"/>
-          </a:solidFill>
-          <a:ln w="9525">
-            <a:solidFill>
-              <a:srgbClr val="E2E8F0"/>
-            </a:solidFill>
-          </a:ln>
-        </p:spPr>
-        <p:style>
-          <a:lnRef idx="1">
-            <a:schemeClr val="accent1"/>
-          </a:lnRef>
-          <a:fillRef idx="3">
-            <a:schemeClr val="accent1"/>
-          </a:fillRef>
-          <a:effectRef idx="2">
-            <a:schemeClr val="accent1"/>
-          </a:effectRef>
-          <a:fontRef idx="minor">
-            <a:schemeClr val="lt1"/>
-          </a:fontRef>
-        </p:style>
-        <p:txBody>
-          <a:bodyPr rtlCol="0" anchor="ctr" wrap="square" tIns="73152" lIns="109728" rIns="109728"/>
-          <a:lstStyle/>
-          <a:p>
-            <a:pPr algn="ctr"/>
-            <a:r>
-              <a:rPr sz="950" b="1">
-                <a:solidFill>
-                  <a:srgbClr val="005A9C"/>
-                </a:solidFill>
-                <a:latin typeface="Georgia"/>
-              </a:rPr>
-              <a:t>实施投入与交付效率对比 (Delivery Efficiency)
-</a:t>
-            </a:r>
-          </a:p>
-          <a:p>
-            <a:pPr>
-              <a:spcBef>
-                <a:spcPts val="300"/>
-              </a:spcBef>
-            </a:pPr>
-            <a:r>
-              <a:rPr sz="800">
-                <a:solidFill>
-                  <a:srgbClr val="334155"/>
-                </a:solidFill>
-                <a:latin typeface="Microsoft YaHei"/>
-              </a:rPr>
-              <a:t>传统定制开发模式： 240 人天 (各组件手工粘合，周期长达 5 个月)
-</a:t>
-            </a:r>
-            <a:r>
-              <a:rPr sz="800" b="1">
-                <a:solidFill>
-                  <a:srgbClr val="10B981"/>
-                </a:solidFill>
-                <a:latin typeface="Microsoft YaHei"/>
-              </a:rPr>
-              <a:t>现代化协同架构模式： 145 人天 (规范驱动 + PaaS全托管，工期提效 ~40%)
-</a:t>
-            </a:r>
-          </a:p>
-          <a:p>
-            <a:pPr>
-              <a:spcBef>
-                <a:spcPts val="300"/>
-              </a:spcBef>
-            </a:pPr>
-            <a:r>
-              <a:rPr sz="700">
-                <a:solidFill>
-                  <a:srgbClr val="64748B"/>
-                </a:solidFill>
-                <a:latin typeface="Microsoft YaHei"/>
-              </a:rPr>
-              <a:t>💡 前置完成网络与治理基线建设，通过 Medallion 标准分层大幅避免后期返工与组件重复建设。</a:t>
-            </a:r>
-          </a:p>
-        </p:txBody>
-      </p:sp>
-      <p:sp>
-        <p:nvSpPr>
-          <p:cNvPr id="11" name="Rounded Rectangle 10"/>
-          <p:cNvSpPr/>
-          <p:nvPr/>
-        </p:nvSpPr>
-        <p:spPr>
-          <a:xfrm>
-            <a:off x="5360212" y="2990088"/>
-            <a:ext cx="3280867" cy="362712"/>
-          </a:xfrm>
-          <a:prstGeom prst="roundRect">
-            <a:avLst/>
-          </a:prstGeom>
-          <a:solidFill>
-            <a:srgbClr val="EAF4FB"/>
-          </a:solidFill>
-          <a:ln w="12700">
-            <a:solidFill>
-              <a:srgbClr val="009CDE"/>
-            </a:solidFill>
-          </a:ln>
-        </p:spPr>
-        <p:style>
-          <a:lnRef idx="1">
-            <a:schemeClr val="accent1"/>
-          </a:lnRef>
-          <a:fillRef idx="3">
-            <a:schemeClr val="accent1"/>
-          </a:fillRef>
-          <a:effectRef idx="2">
-            <a:schemeClr val="accent1"/>
-          </a:effectRef>
-          <a:fontRef idx="minor">
-            <a:schemeClr val="lt1"/>
-          </a:fontRef>
-        </p:style>
-        <p:txBody>
-          <a:bodyPr rtlCol="0" anchor="ctr" wrap="square" tIns="36576" bIns="18288"/>
-          <a:lstStyle/>
-          <a:p>
-            <a:pPr algn="ctr"/>
-            <a:r>
-              <a:rPr sz="1100" b="1">
-                <a:solidFill>
-                  <a:srgbClr val="005A9C"/>
-                </a:solidFill>
-                <a:latin typeface="Georgia"/>
-              </a:rPr>
-              <a:t>95 人天  </a:t>
-            </a:r>
-            <a:r>
-              <a:rPr sz="750">
-                <a:solidFill>
-                  <a:srgbClr val="334155"/>
-                </a:solidFill>
-                <a:latin typeface="Microsoft YaHei"/>
-              </a:rPr>
-              <a:t>~40% 交付工期与人天净节省</a:t>
-            </a:r>
-          </a:p>
-        </p:txBody>
-      </p:sp>
-      <p:sp>
-        <p:nvSpPr>
-          <p:cNvPr id="12" name="Rounded Rectangle 11"/>
-          <p:cNvSpPr/>
-          <p:nvPr/>
-        </p:nvSpPr>
-        <p:spPr>
-          <a:xfrm>
-            <a:off x="5360212" y="3425952"/>
-            <a:ext cx="3280867" cy="362712"/>
-          </a:xfrm>
-          <a:prstGeom prst="roundRect">
-            <a:avLst/>
-          </a:prstGeom>
-          <a:solidFill>
-            <a:srgbClr val="F8FAFC"/>
-          </a:solidFill>
-          <a:ln w="6350">
-            <a:solidFill>
-              <a:srgbClr val="CBD5E1"/>
-            </a:solidFill>
-          </a:ln>
-        </p:spPr>
-        <p:style>
-          <a:lnRef idx="1">
-            <a:schemeClr val="accent1"/>
-          </a:lnRef>
-          <a:fillRef idx="3">
-            <a:schemeClr val="accent1"/>
-          </a:fillRef>
-          <a:effectRef idx="2">
-            <a:schemeClr val="accent1"/>
-          </a:effectRef>
-          <a:fontRef idx="minor">
-            <a:schemeClr val="lt1"/>
-          </a:fontRef>
-        </p:style>
-        <p:txBody>
-          <a:bodyPr rtlCol="0" anchor="ctr" wrap="square" tIns="36576" bIns="18288"/>
-          <a:lstStyle/>
-          <a:p>
-            <a:pPr algn="ctr"/>
-            <a:r>
-              <a:rPr sz="1100" b="1">
-                <a:solidFill>
-                  <a:srgbClr val="005A9C"/>
-                </a:solidFill>
-                <a:latin typeface="Georgia"/>
-              </a:rPr>
-              <a:t>10 周  </a:t>
-            </a:r>
-            <a:r>
-              <a:rPr sz="750">
-                <a:solidFill>
-                  <a:srgbClr val="334155"/>
-                </a:solidFill>
-                <a:latin typeface="Microsoft YaHei"/>
-              </a:rPr>
-              <a:t>约 2.5 个月完成全平台投产上线</a:t>
-            </a:r>
-          </a:p>
-        </p:txBody>
-      </p:sp>
-      <p:sp>
-        <p:nvSpPr>
-          <p:cNvPr id="13" name="Rounded Rectangle 12"/>
-          <p:cNvSpPr/>
-          <p:nvPr/>
-        </p:nvSpPr>
-        <p:spPr>
-          <a:xfrm>
-            <a:off x="5360212" y="3861816"/>
-            <a:ext cx="3280867" cy="362712"/>
-          </a:xfrm>
-          <a:prstGeom prst="roundRect">
-            <a:avLst/>
-          </a:prstGeom>
-          <a:solidFill>
-            <a:srgbClr val="F8FAFC"/>
-          </a:solidFill>
-          <a:ln w="6350">
-            <a:solidFill>
-              <a:srgbClr val="CBD5E1"/>
-            </a:solidFill>
-          </a:ln>
-        </p:spPr>
-        <p:style>
-          <a:lnRef idx="1">
-            <a:schemeClr val="accent1"/>
-          </a:lnRef>
-          <a:fillRef idx="3">
-            <a:schemeClr val="accent1"/>
-          </a:fillRef>
-          <a:effectRef idx="2">
-            <a:schemeClr val="accent1"/>
-          </a:effectRef>
-          <a:fontRef idx="minor">
-            <a:schemeClr val="lt1"/>
-          </a:fontRef>
-        </p:style>
-        <p:txBody>
-          <a:bodyPr rtlCol="0" anchor="ctr" wrap="square" tIns="36576" bIns="18288"/>
-          <a:lstStyle/>
-          <a:p>
-            <a:pPr algn="ctr"/>
-            <a:r>
-              <a:rPr sz="1100" b="1">
-                <a:solidFill>
-                  <a:srgbClr val="005A9C"/>
-                </a:solidFill>
-                <a:latin typeface="Georgia"/>
-              </a:rPr>
-              <a:t>3-4 人  </a:t>
-            </a:r>
-            <a:r>
-              <a:rPr sz="750">
-                <a:solidFill>
-                  <a:srgbClr val="334155"/>
-                </a:solidFill>
-                <a:latin typeface="Microsoft YaHei"/>
-              </a:rPr>
-              <a:t>精益核心交付团队 (云架构+数仓+BI)</a:t>
-            </a:r>
-          </a:p>
-        </p:txBody>
-      </p:sp>
-      <p:sp>
-        <p:nvSpPr>
-          <p:cNvPr id="14" name="Rounded Rectangle 13"/>
-          <p:cNvSpPr/>
-          <p:nvPr/>
-        </p:nvSpPr>
-        <p:spPr>
-          <a:xfrm>
-            <a:off x="502920" y="4462272"/>
-            <a:ext cx="8138159" cy="384048"/>
-          </a:xfrm>
-          <a:prstGeom prst="roundRect">
-            <a:avLst/>
-          </a:prstGeom>
-          <a:solidFill>
-            <a:srgbClr val="EAF4FB"/>
-          </a:solidFill>
-          <a:ln w="12700">
-            <a:solidFill>
-              <a:srgbClr val="009CDE"/>
-            </a:solidFill>
-          </a:ln>
-        </p:spPr>
-        <p:style>
-          <a:lnRef idx="1">
-            <a:schemeClr val="accent1"/>
-          </a:lnRef>
-          <a:fillRef idx="3">
-            <a:schemeClr val="accent1"/>
-          </a:fillRef>
-          <a:effectRef idx="2">
-            <a:schemeClr val="accent1"/>
-          </a:effectRef>
-          <a:fontRef idx="minor">
-            <a:schemeClr val="lt1"/>
-          </a:fontRef>
-        </p:style>
-        <p:txBody>
-          <a:bodyPr rtlCol="0" anchor="ctr" wrap="square" tIns="54864" bIns="54864" lIns="137160" rIns="137160"/>
-          <a:lstStyle/>
-          <a:p>
-            <a:pPr algn="ctr"/>
-            <a:r>
-              <a:rPr sz="850" b="1">
-                <a:solidFill>
-                  <a:srgbClr val="005A9C"/>
-                </a:solidFill>
-                <a:latin typeface="Microsoft YaHei"/>
-              </a:rPr>
-              <a:t>【实施建议】 </a:t>
-            </a:r>
-            <a:r>
-              <a:rPr sz="850" b="0">
-                <a:solidFill>
-                  <a:srgbClr val="0F172A"/>
-                </a:solidFill>
-                <a:latin typeface="Microsoft YaHei"/>
-              </a:rPr>
-              <a:t>建议采取敏捷迭代交付模式：以首批高频业务系统打通全链路闭环，形成可复制标准，后续系统接入即可实现流水线式快速迁移。</a:t>
             </a:r>
           </a:p>
         </p:txBody>

</xml_diff>